<commit_message>
TC5-8 y costeo: se elimina por ahora la suscripción; el pack de 12 se vende por pedido
Co-Authored-By: Claude Opus 5.5 <noreply@anthropic.com>
Claude-Session: https://claude.ai/code/session_01Kfbf7cfV7pXUcNjjyaPCzV
</commit_message>
<xml_diff>
--- a/04-reformulacion/TC5-8/TC5-8-AndiBite.pptx
+++ b/04-reformulacion/TC5-8/TC5-8-AndiBite.pptx
@@ -133,13 +133,13 @@
   <p:extLst>
     <p:ext uri="{521415D9-36F7-43E2-AB2F-B90AF26B5E84}">
       <p14:sectionLst xmlns:p14="http://schemas.microsoft.com/office/powerpoint/2010/main">
-        <p14:section name="Portada" id="{46ce0402-7536-553e-b83f-933f7a2c06db}">
+        <p14:section name="Portada" id="{dc06b089-9d59-bc08-8c12-ec7acf067954}">
           <p14:sldIdLst>
             <p14:sldId id="256"/>
             <p14:sldId id="257"/>
           </p14:sldIdLst>
         </p14:section>
-        <p14:section name="TC5 · Cliente, mercado y canal" id="{27758822-e03a-3e98-102c-52a3ef4277d7}">
+        <p14:section name="TC5 · Cliente, mercado y canal" id="{8d8d27a5-0685-5a67-59ff-8ecb22329587}">
           <p14:sldIdLst>
             <p14:sldId id="258"/>
             <p14:sldId id="259"/>
@@ -151,7 +151,7 @@
             <p14:sldId id="265"/>
           </p14:sldIdLst>
         </p14:section>
-        <p14:section name="TC6 · Relación e ingresos" id="{8625f247-3376-9492-bf9e-536863df9601}">
+        <p14:section name="TC6 · Relación e ingresos" id="{d74aa633-adeb-b6ce-84e3-0ec50a235b49}">
           <p14:sldIdLst>
             <p14:sldId id="266"/>
             <p14:sldId id="267"/>
@@ -160,7 +160,7 @@
             <p14:sldId id="270"/>
           </p14:sldIdLst>
         </p14:section>
-        <p14:section name="TC7 · Canvas" id="{e517f6f1-df49-0e08-ff61-8d0ba316d6df}">
+        <p14:section name="TC7 · Canvas" id="{a76c293f-4d07-aab4-3ac4-18fe02eb3866}">
           <p14:sldIdLst>
             <p14:sldId id="271"/>
             <p14:sldId id="272"/>
@@ -171,7 +171,7 @@
             <p14:sldId id="277"/>
           </p14:sldIdLst>
         </p14:section>
-        <p14:section name="TC8 · Propuesta de valor" id="{667d0f95-adf1-3b03-251d-984db9c87792}">
+        <p14:section name="TC8 · Propuesta de valor" id="{25ef3c35-3343-ba25-c258-5f58c6ff192e}">
           <p14:sldIdLst>
             <p14:sldId id="278"/>
             <p14:sldId id="279"/>
@@ -179,7 +179,7 @@
             <p14:sldId id="281"/>
           </p14:sldIdLst>
         </p14:section>
-        <p14:section name="Cierre" id="{d8ef73bc-1653-00f9-1666-f9011b42768c}">
+        <p14:section name="Cierre" id="{54fb7252-d3e5-39b0-5a54-b29dcddd043f}">
           <p14:sldIdLst>
             <p14:sldId id="282"/>
           </p14:sldIdLst>
@@ -4129,7 +4129,7 @@
           <a:p>
             <a:r>
               <a:rPr lang="en-US" dirty="0"/>
-              <a:t>Los seis tipos de relación de Osterwalder y cómo los usa AndiBite. Las tres fuertes (asistencia personal por WhatsApp, suscripción automática y comunidad de mamás embajadoras) sostienen la recompra; las de apoyo crecen con el volumen. Con los colegios y naturistas la relación es exclusiva: un socio responde por cada cuenta.</a:t>
+              <a:t>Los seis tipos de relación de Osterwalder y cómo los usa AndiBite. Las tres fuertes (asistencia personal por WhatsApp, recordatorio automático de recompra y comunidad de mamás embajadoras) sostienen la recompra; las de apoyo crecen con el volumen. Con los colegios y naturistas la relación es exclusiva: un socio responde por cada cuenta.</a:t>
             </a:r>
             <a:endParaRPr lang="en-US" dirty="0"/>
           </a:p>
@@ -4217,7 +4217,7 @@
           <a:p>
             <a:r>
               <a:rPr lang="en-US" dirty="0"/>
-              <a:t>Captar: la caja degustación (3 brownies a S/4 = S/12) hace que el niño pruebe delante de la madre; el cupón de S/3 empuja el primer pack. Fidelizar: suscripción quincenal con recordatorio por WhatsApp dos días antes. Crecer: mamá embajadora por salón y paso al pack de 12. Metas del documento 07: 300 familias en espera, 35 % de recompra a 60 días, 700 hogares activos.
+              <a:t>Captar: la caja degustación (3 brownies a S/4 = S/12) hace que el niño pruebe delante de la madre; el cupón de S/3 empuja el primer pack. Fidelizar: recordatorio por WhatsApp cuando el pack está por acabarse (unos 12 días después de la compra), sin suscripción ni compromiso. Crecer: mamá embajadora por salón y paso al pack de 12. Metas del documento 07: 300 familias en espera, 35 % de recompra a 60 días, 700 hogares activos.
 IMAGEN 3 — prompt para Nano Banana (proporción 9:16 · adjuntar la foto del empaque):
 Use the attached AndiBite package image only as a reference for the brand colors and the product. Top-down flat-lay photo of an open children's school lunchbox on a light wooden table: one mini chocolate brownie (about 5 x 3 cm, fudgy, dark cocoa color, crackly top) inside a small clear individual bag, fresh strawberries and banana slices in a small container, a reusable water bottle and a folded cloth napkin. Next to the lunchbox, the AndiBite stand-up pouch from the reference, slightly out of focus, label turned partly away. Soft natural morning light, clean food styling, warm palette of cream and chocolate brown with brick red accents. Vertical 9:16 composition, lunchbox centered, calm empty area at the top. Do not invent or rewrite any text on the package, no extra logos, no watermark.</a:t>
             </a:r>
@@ -4307,7 +4307,7 @@
           <a:p>
             <a:r>
               <a:rPr lang="en-US" dirty="0"/>
-              <a:t>Tipos de ingreso (Osterwalder): venta de activos (packs y unidades), suscripción (pack de 12 cada dos semanas), venta mayorista B2B y eventos. Porcentajes sobre las ventas con IGV del año 1 (S/302,900), hoja Proyeccion del Excel. Mecanismo de precio: fijo por lista, con descuento por volumen. Precios confirmados por el equipo el 9 de octubre de 2026.</a:t>
+              <a:t>Tipos de ingreso (Osterwalder): venta de activos (packs y unidades), venta por volumen (pack de 12), venta mayorista B2B y eventos. Porcentajes sobre las ventas con IGV del año 1 (S/302,900), hoja Proyeccion del Excel. Mecanismo de precio: fijo por lista, con descuento por volumen. Precios confirmados por el equipo el 9 de octubre de 2026.</a:t>
             </a:r>
             <a:endParaRPr lang="en-US" dirty="0"/>
           </a:p>
@@ -10986,7 +10986,7 @@
                   <a:schemeClr val="tx1"/>
                 </a:solidFill>
               </a:rPr>
-              <a:t>Suscripción quincenal con recordatorio 2 días antes</a:t>
+              <a:t>Recordatorio de recompra por WhatsApp a los 12 días</a:t>
             </a:r>
             <a:endParaRPr lang="en-US" sz="1500" dirty="0"/>
           </a:p>
@@ -11978,7 +11978,7 @@
                   <a:schemeClr val="tx1"/>
                 </a:solidFill>
               </a:rPr>
-              <a:t>Suscripción quincenal con recordatorio y cambio de sabores sin costo</a:t>
+              <a:t>Recordatorio de recompra por WhatsApp y cambio de sabores en cada pedido</a:t>
             </a:r>
             <a:endParaRPr lang="en-US" sz="1500" dirty="0"/>
           </a:p>
@@ -12886,7 +12886,7 @@
                   <a:schemeClr val="tx2"/>
                 </a:solidFill>
               </a:rPr>
-              <a:t>Suscripción "Semana completa"</a:t>
+              <a:t>Pack de 12 "Semana completa"</a:t>
             </a:r>
             <a:endParaRPr lang="en-US" sz="1400" dirty="0"/>
           </a:p>
@@ -12900,7 +12900,7 @@
                   <a:schemeClr val="accent2"/>
                 </a:solidFill>
               </a:rPr>
-              <a:t>Pack de 12 cada dos semanas: S/3.91 por brownie</a:t>
+              <a:t>Venta por volumen: S/3.91 por brownie</a:t>
             </a:r>
             <a:endParaRPr lang="en-US" sz="1400" dirty="0"/>
           </a:p>
@@ -21575,7 +21575,7 @@
                   <a:schemeClr val="tx1"/>
                 </a:solidFill>
               </a:rPr>
-              <a:t>Suscripción quincenal</a:t>
+              <a:t>Recordatorio de recompra</a:t>
             </a:r>
             <a:endParaRPr lang="en-US" sz="1300" dirty="0"/>
           </a:p>
@@ -22971,7 +22971,7 @@
                   <a:schemeClr val="tx1"/>
                 </a:solidFill>
               </a:rPr>
-              <a:t>Suscripción por WhatsApp</a:t>
+              <a:t>Pedido por WhatsApp</a:t>
             </a:r>
             <a:endParaRPr lang="en-US" sz="1200" dirty="0"/>
           </a:p>
@@ -34997,7 +34997,7 @@
                   <a:schemeClr val="tx1"/>
                 </a:solidFill>
               </a:rPr>
-              <a:t>Suscripción con recordatorio</a:t>
+              <a:t>Recordatorio para recomprar</a:t>
             </a:r>
             <a:endParaRPr lang="en-US" sz="1400" dirty="0"/>
           </a:p>
@@ -35907,7 +35907,7 @@
                   <a:schemeClr val="tx1"/>
                 </a:solidFill>
               </a:rPr>
-              <a:t>Recordatorio quincenal y cambio de sabores</a:t>
+              <a:t>Recordatorio de recompra y cambio de sabores</a:t>
             </a:r>
             <a:endParaRPr lang="en-US" sz="1400" dirty="0"/>
           </a:p>

</xml_diff>

<commit_message>
Capturas reales de la app en la TC5-8 y nueva diapositiva de la app en la T1
TC5-8: la diapositiva 30 muestra la pantalla del lote. T1: diapositiva 12 con tres pantallas del prototipo y la agenda y el guion ajustados a 23 diapositivas. Documento 09: sección del prototipo funcional y códigos de demostración.

Co-Authored-By: Claude Opus 5.5 <noreply@anthropic.com>
Claude-Session: https://claude.ai/code/session_01Kfbf7cfV7pXUcNjjyaPCzV
</commit_message>
<xml_diff>
--- a/04-reformulacion/TC5-8/TC5-8-AndiBite.pptx
+++ b/04-reformulacion/TC5-8/TC5-8-AndiBite.pptx
@@ -139,13 +139,13 @@
   <p:extLst>
     <p:ext uri="{521415D9-36F7-43E2-AB2F-B90AF26B5E84}">
       <p14:sectionLst xmlns:p14="http://schemas.microsoft.com/office/powerpoint/2010/main">
-        <p14:section name="Portada" id="{c3b8bb69-b414-c396-18b3-a7f853d6049f}">
+        <p14:section name="Portada" id="{4c795153-3cd4-c4a3-aadf-f844837d4321}">
           <p14:sldIdLst>
             <p14:sldId id="256"/>
             <p14:sldId id="257"/>
           </p14:sldIdLst>
         </p14:section>
-        <p14:section name="TC5 · Cliente, mercado y canal" id="{c75fdb58-3a5e-814a-8b50-0f6439749379}">
+        <p14:section name="TC5 · Cliente, mercado y canal" id="{4746032b-3452-395b-3386-825426b4530b}">
           <p14:sldIdLst>
             <p14:sldId id="258"/>
             <p14:sldId id="259"/>
@@ -159,7 +159,7 @@
             <p14:sldId id="267"/>
           </p14:sldIdLst>
         </p14:section>
-        <p14:section name="TC6 · Relación e ingresos" id="{067a395e-ce24-4e78-513e-f5a3ef12b990}">
+        <p14:section name="TC6 · Relación e ingresos" id="{8db1e8ed-3749-9f96-bd74-8ddf75eb184e}">
           <p14:sldIdLst>
             <p14:sldId id="268"/>
             <p14:sldId id="269"/>
@@ -168,7 +168,7 @@
             <p14:sldId id="272"/>
           </p14:sldIdLst>
         </p14:section>
-        <p14:section name="TC7 · Canvas" id="{0b9c3147-6d48-d61c-817e-90ab944da897}">
+        <p14:section name="TC7 · Canvas" id="{d9c34a8d-6b2f-16e9-aa2f-73bcbf15a391}">
           <p14:sldIdLst>
             <p14:sldId id="273"/>
             <p14:sldId id="274"/>
@@ -181,7 +181,7 @@
             <p14:sldId id="281"/>
           </p14:sldIdLst>
         </p14:section>
-        <p14:section name="TC8 · Propuesta de valor" id="{3ea92967-6eeb-7a23-3396-5ba5b4f6efc0}">
+        <p14:section name="TC8 · Propuesta de valor" id="{49e6a841-7735-e0c3-ddf5-36f370b496e9}">
           <p14:sldIdLst>
             <p14:sldId id="282"/>
             <p14:sldId id="283"/>
@@ -191,7 +191,7 @@
             <p14:sldId id="287"/>
           </p14:sldIdLst>
         </p14:section>
-        <p14:section name="Cierre" id="{aa15a221-9c37-1279-6c02-4149f3c5b515}">
+        <p14:section name="Cierre" id="{9798b3e6-4dcc-d621-3685-86124c6b2bc4}">
           <p14:sldIdLst>
             <p14:sldId id="288"/>
           </p14:sldIdLst>
@@ -37341,36 +37341,9 @@
           </a:p>
         </p:txBody>
       </p:sp>
-      <p:sp>
-        <p:nvSpPr>
-          <p:cNvPr id="40" name="IMAGEN_5"/>
-          <p:cNvSpPr/>
-          <p:nvPr/>
-        </p:nvSpPr>
-        <p:spPr>
-          <a:xfrm>
-            <a:off x="9281160" y="1463040"/>
-            <a:ext cx="2359152" cy="4069080"/>
-          </a:xfrm>
-          <a:prstGeom prst="roundRect">
-            <a:avLst>
-              <a:gd name="adj" fmla="val 5814"/>
-            </a:avLst>
-          </a:prstGeom>
-          <a:solidFill>
-            <a:srgbClr val="F0E2CF"/>
-          </a:solidFill>
-          <a:ln w="19050">
-            <a:solidFill>
-              <a:schemeClr val="accent5"/>
-            </a:solidFill>
-            <a:prstDash val="dash"/>
-          </a:ln>
-        </p:spPr>
-      </p:sp>
       <p:pic>
         <p:nvPicPr>
-          <p:cNvPr id="41" name="Image 10" descr="preencoded.png">    </p:cNvPr>
+          <p:cNvPr id="40" name="Image 10" descr="img/app-lote.png">    </p:cNvPr>
           <p:cNvPicPr>
             <a:picLocks noChangeAspect="1"/>
           </p:cNvPicPr>
@@ -37384,8 +37357,8 @@
         </p:blipFill>
         <p:spPr>
           <a:xfrm>
-            <a:off x="10094976" y="2583180"/>
-            <a:ext cx="731520" cy="731520"/>
+            <a:off x="9445752" y="1371600"/>
+            <a:ext cx="2029968" cy="4096512"/>
           </a:xfrm>
           <a:prstGeom prst="rect">
             <a:avLst/>
@@ -37394,71 +37367,7 @@
       </p:pic>
       <p:sp>
         <p:nvSpPr>
-          <p:cNvPr id="42" name="Text 29"/>
-          <p:cNvSpPr txBox="1"/>
-          <p:nvPr/>
-        </p:nvSpPr>
-        <p:spPr>
-          <a:xfrm>
-            <a:off x="9464040" y="3497580"/>
-            <a:ext cx="1993392" cy="1097280"/>
-          </a:xfrm>
-          <a:prstGeom prst="rect">
-            <a:avLst/>
-          </a:prstGeom>
-          <a:noFill/>
-          <a:ln/>
-        </p:spPr>
-        <p:txBody>
-          <a:bodyPr wrap="square" lIns="0" tIns="0" rIns="0" bIns="0" rtlCol="0" anchor="t"/>
-          <a:lstStyle/>
-          <a:p>
-            <a:pPr algn="ctr" indent="0" marL="0">
-              <a:buNone/>
-            </a:pPr>
-            <a:r>
-              <a:rPr lang="en-US" sz="1600" b="1" dirty="0">
-                <a:solidFill>
-                  <a:schemeClr val="accent2"/>
-                </a:solidFill>
-              </a:rPr>
-              <a:t>IMAGEN 5</a:t>
-            </a:r>
-            <a:endParaRPr lang="en-US" sz="1400" dirty="0"/>
-          </a:p>
-          <a:p>
-            <a:pPr algn="ctr" indent="0" marL="0">
-              <a:buNone/>
-            </a:pPr>
-            <a:r>
-              <a:rPr lang="en-US" sz="1300" dirty="0">
-                <a:solidFill>
-                  <a:schemeClr val="accent2"/>
-                </a:solidFill>
-              </a:rPr>
-              <a:t>Pantallas de la app</a:t>
-            </a:r>
-            <a:endParaRPr lang="en-US" sz="1400" dirty="0"/>
-          </a:p>
-          <a:p>
-            <a:pPr algn="ctr" indent="0" marL="0">
-              <a:buNone/>
-            </a:pPr>
-            <a:r>
-              <a:rPr lang="en-US" sz="1100" i="1" dirty="0">
-                <a:solidFill>
-                  <a:schemeClr val="accent2"/>
-                </a:solidFill>
-              </a:rPr>
-              <a:t>Prompt en las notas del orador</a:t>
-            </a:r>
-            <a:endParaRPr lang="en-US" sz="1400" dirty="0"/>
-          </a:p>
-        </p:txBody>
-      </p:sp>
-      <p:sp>
-        <p:nvSpPr>
-          <p:cNvPr id="43" name="Shape 30"/>
+          <p:cNvPr id="41" name="Shape 28"/>
           <p:cNvSpPr/>
           <p:nvPr/>
         </p:nvSpPr>
@@ -37485,7 +37394,7 @@
       </p:sp>
       <p:sp>
         <p:nvSpPr>
-          <p:cNvPr id="44" name="Text 31"/>
+          <p:cNvPr id="42" name="Text 29"/>
           <p:cNvSpPr txBox="1"/>
           <p:nvPr/>
         </p:nvSpPr>

</xml_diff>

<commit_message>
Público A y B con esfuerzo parejo: buyer persona del segmento B, puntos de venta y colegios
- Rodrigo pasa a representar al segmento B (40, San Miguel, hogar de
  unos S/8,500), con datos de APEIM 2025; Claudia queda como segmento A.
- Puntos de venta repartidos entre A y B: Jockey (A y B), Real Plaza
  Salaverry u Open Plaza Angamos (B), La Rambla o Wong/Vivanda (A);
  carrito también en Plaza Vea.
- Colegios de los dos segmentos: pensión alta (A) y cadenas como
  Innova Schools (B), con la norma de quioscos sin octógonos.
- Documentos 04, 07, 08 y 09 y la TC5-8 actualizados. Las cifras del
  plan no cambian.

Co-Authored-By: Claude Opus 5.5 <noreply@anthropic.com>
Claude-Session: https://claude.ai/code/session_01Kfbf7cfV7pXUcNjjyaPCzV
</commit_message>
<xml_diff>
--- a/04-reformulacion/TC5-8/TC5-8-AndiBite.pptx
+++ b/04-reformulacion/TC5-8/TC5-8-AndiBite.pptx
@@ -142,13 +142,13 @@
   <p:extLst>
     <p:ext uri="{521415D9-36F7-43E2-AB2F-B90AF26B5E84}">
       <p14:sectionLst xmlns:p14="http://schemas.microsoft.com/office/powerpoint/2010/main">
-        <p14:section name="Portada" id="{b02311f9-57e7-9871-3c5c-95406bfc24ef}">
+        <p14:section name="Portada" id="{9f06238e-bae5-77e5-bbb9-fbbed74f096b}">
           <p14:sldIdLst>
             <p14:sldId id="256"/>
             <p14:sldId id="257"/>
           </p14:sldIdLst>
         </p14:section>
-        <p14:section name="TC5 · Cliente, mercado y canal" id="{b4352997-dc69-dd25-d76a-76e6266e3687}">
+        <p14:section name="TC5 · Cliente, mercado y canal" id="{76ca459e-9410-98a4-c60e-0c7d210f1868}">
           <p14:sldIdLst>
             <p14:sldId id="258"/>
             <p14:sldId id="259"/>
@@ -162,7 +162,7 @@
             <p14:sldId id="267"/>
           </p14:sldIdLst>
         </p14:section>
-        <p14:section name="TC6 · Relación e ingresos" id="{6ae8360d-f5e1-daa1-19ba-672c59a191a8}">
+        <p14:section name="TC6 · Relación e ingresos" id="{e56c48f2-4a9d-c768-94e3-f752d3fd75ed}">
           <p14:sldIdLst>
             <p14:sldId id="268"/>
             <p14:sldId id="269"/>
@@ -171,7 +171,7 @@
             <p14:sldId id="272"/>
           </p14:sldIdLst>
         </p14:section>
-        <p14:section name="TC7 · Canvas" id="{e6a882ea-72ae-8ef7-a33f-0c54f36013c1}">
+        <p14:section name="TC7 · Canvas" id="{78d57c94-d486-6f97-9ae1-e924219b8c6d}">
           <p14:sldIdLst>
             <p14:sldId id="273"/>
             <p14:sldId id="274"/>
@@ -185,7 +185,7 @@
             <p14:sldId id="282"/>
           </p14:sldIdLst>
         </p14:section>
-        <p14:section name="TC8 · Propuesta de valor" id="{c8e8e350-9241-21e6-4347-83d5e8b6cce1}">
+        <p14:section name="TC8 · Propuesta de valor" id="{dd8e6ed5-dab8-70cb-d3ae-a259cf5b9074}">
           <p14:sldIdLst>
             <p14:sldId id="283"/>
             <p14:sldId id="284"/>
@@ -196,7 +196,7 @@
             <p14:sldId id="289"/>
           </p14:sldIdLst>
         </p14:section>
-        <p14:section name="Cierre" id="{b54f34a6-6627-6980-7af5-1ef2ddbef0a0}">
+        <p14:section name="Cierre" id="{609ce8b3-dd19-989b-dadc-0a2601b7ce1e}">
           <p14:sldIdLst>
             <p14:sldId id="290"/>
             <p14:sldId id="291"/>
@@ -5766,7 +5766,7 @@
           <a:p>
             <a:r>
               <a:rPr lang="en-US" dirty="0"/>
-              <a:t>Puntos de venta (documento 08): programas para emprendedores de Jockey Plaza, Larcomar (El Mercadito del Emprendedor) y La Rambla San Borja; carrito en la entrada de Wong o Vivanda; 2 ferias pagadas, de campaña escolar (febrero) y del Día del Niño Peruano (segundo domingo de abril); kermeses, cumpleaños y ferias saludables o municipales, que no cobran stand. Las ferias navideñas se sacaron del plan: con unos 700 brownies, una feria de S/1,800 pierde dinero si no deja clientes que vuelvan. Plan: 1 punto en enero, 2 de febrero a julio y 3 de agosto a diciembre de 2027, solo fines de semana. Cada punto y cada evento lo atiende un(a) vendedor(a) pagado(a) a S/90 por día; el espacio cuesta S/600 por punto al mes y el stand en feria, S/1,800 más 3 días de vendedor(a).</a:t>
+              <a:t>Puntos de venta (documento 08), repartidos para llegar con el mismo esfuerzo al padre A y al padre B. Malls: Jockey Plaza y La Rambla San Borja (Lima Top, A y B); Real Plaza Salaverry (Jesús María, Lima Moderna), con la Placita del Emprendimiento del programa Perú Pasión de Intercorp, y Open Plaza Angamos (Surquillo), con el programa Open Emerge de espacios para emprendedores (público B); Larcomar queda como alternativa. Carrito en Wong o Vivanda (A) y en Plaza Vea (B). Orden de apertura: 1.er punto en enero en Jockey (A y B), 2.º punto en febrero en Real Plaza Salaverry u Open Plaza Angamos (B) y 3.er punto en agosto en La Rambla o en el carrito de Wong o Vivanda (A). Colegios: quioscos y kermeses en colegios de pensión alta de Lima Top (A) y en cadenas de pensión media como Innova Schools (39 sedes en Lima, B); un solo acuerdo con una cadena abre varias sedes. El quiosco solo puede vender productos sin octógonos (lineamientos de alimentación saludable del MINSA y la RVM 076-2019-MINEDU), por eso el brownie sin octógono es la llave de entrada; el quiosco lo opera un concesionario elegido por el colegio. 2 ferias pagadas, de campaña escolar (febrero) y del Día del Niño Peruano (segundo domingo de abril); kermeses, cumpleaños y ferias saludables o municipales, que no cobran stand. Las ferias navideñas se sacaron del plan: con unos 700 brownies, una feria de S/1,800 pierde dinero si no deja clientes que vuelvan. Plan: 1 punto en enero, 2 de febrero a julio y 3 de agosto a diciembre de 2027, solo fines de semana. Cada punto y cada evento lo atiende un(a) vendedor(a) pagado(a) a S/90 por día; el espacio cuesta S/600 por punto al mes y el stand en feria, S/1,800 más 3 días de vendedor(a).</a:t>
             </a:r>
             <a:endParaRPr lang="en-US" dirty="0"/>
           </a:p>
@@ -8146,7 +8146,7 @@
           <a:p>
             <a:r>
               <a:rPr lang="en-US" dirty="0"/>
-              <a:t>Sesión 05: el público objetivo orienta (un rango de edad, NSE y distrito) y el arquetipo conecta (una persona con nombre, dolor y hábito). Regla de 3 de la clase: nombre, dolor y hábito. Le vendemos a Claudia, no a "madres de 32 a 45". Datos: APEIM 2025, CPI 2026 y documento 04.</a:t>
+              <a:t>Sesión 05: el público objetivo orienta (un rango de edad, NSE y distrito) y el arquetipo conecta (una persona con nombre, dolor y hábito). Regla de 3 de la clase: nombre, dolor y hábito. Le vendemos a Claudia y a Rodrigo, no a "madres de 32 a 45". Atendemos a los dos segmentos con el mismo esfuerzo: en Lima Top (zona 7 de APEIM) el 51.4 % de los hogares es B y el 20.2 % es A, y en Lima Moderna (zona 6) 51.7 % B y 11.8 % A; o sea, unos 7 de cada 10 hogares A/B de esas zonas son B. Datos: APEIM 2025, CPI 2026 y documento 04.</a:t>
             </a:r>
             <a:endParaRPr lang="en-US" dirty="0"/>
           </a:p>
@@ -8234,7 +8234,7 @@
           <a:p>
             <a:r>
               <a:rPr lang="en-US" dirty="0"/>
-              <a:t>Partes esenciales de un arquetipo según la sesión 05: nombre, edad y ocupación; hábitos, frustraciones y valores; canales y comportamiento de compra. Guardiana del Hierro (la representa Claudia), El Resolutivo (Rodrigo) y El Consejero (quiosco, nutricionista o pediatra: en marketing se le llama prescriptor), que recomienda la marca a los otros dos. Los porcentajes son el peso esperado de cada arquetipo en el volumen.</a:t>
+              <a:t>Partes esenciales de un arquetipo según la sesión 05: nombre, edad y ocupación; hábitos, frustraciones y valores; canales y comportamiento de compra. Guardiana del Hierro (la representa Claudia, segmento A), El Resolutivo (Rodrigo, segmento B) y El Consejero (quiosco, nutricionista o pediatra: en marketing se le llama prescriptor), que recomienda la marca a los otros dos. Los porcentajes son el peso esperado de cada arquetipo en el volumen.</a:t>
             </a:r>
             <a:endParaRPr lang="en-US" dirty="0"/>
           </a:p>
@@ -8412,9 +8412,9 @@
           <a:p>
             <a:r>
               <a:rPr lang="en-US" dirty="0"/>
-              <a:t>Rodrigo Salazar, 42 años, La Molina. Gerente de operaciones; su esposa viaja por trabajo y él arma las loncheras. Ingreso familiar S/18,000 (hipótesis, A2). No busca salud, busca resolver: un pack que dure la semana, que aguante la mochila y que pueda pedir por WhatsApp con recordatorio. El pack de 12 por WhatsApp a S/49.90 equivale a S/24.95 por cada 6, en el borde de lo que pagaría (S/18 a 24): lo que justifica la diferencia es que la app le arma las loncheras y le avisa antes de que se acabe el pack.
+              <a:t>Rodrigo Salazar, 40 años, San Miguel (zona 6 de APEIM, Lima Moderna: 51.7 % de los hogares es B). Representa al segmento B, que son 7 de cada 10 hogares A/B de Lima Top y Moderna. Jefe de logística en una empresa de consumo masivo; su esposa es analista contable y los dos trabajan. Ingreso familiar S/8,500 al mes (hipótesis dentro del NSE B: el promedio B de APEIM 2025 es S/7,787 y el A, S/14,584). Sus hijos de 9 y 6 van a un colegio privado de pensión media (en Lima, de S/400 a 900 al mes por hijo según cuantomecuesta.com, abril de 2026). Él arma las loncheras de la mañana. No busca salud, busca resolver: un pack que dure la semana, que aguante la mochila y que pueda pedir por WhatsApp con recordatorio. Compra en Plaza Vea y Tottus, por apps y por WhatsApp; se entera por el chat del salón. Mira el precio por brownie: el pack de 6 a S/4.48 por WhatsApp está dentro de lo que pagaría (S/18 a 24 por 6, o S/3 a 4 por unidad), y el pack de 12 a S/49.90 (S/24.95 por cada 6) queda en el borde; lo justifican el hierro medido, la app que le arma las loncheras y el aviso antes de que se acabe el pack. Dónde lo encontramos: Real Plaza Salaverry y Open Plaza Angamos, el carrito en Plaza Vea y las kermeses de su colegio.
 IMAGEN 2 — prompt para Nano Banana (proporción 3:4):
-Photorealistic editorial portrait of a 42-year-old Peruvian man, an operations manager from La Molina, Lima. Short dark hair with a few grey strands, light stubble, friendly and practical expression, slightly hurried morning energy. He wears a navy quarter-zip sweater over a light blue shirt and a smartwatch. Early morning in a modern home kitchen: he holds his phone in one hand (a chat app on screen, not legible) while closing a child's school lunchbox with the other. Warm morning light, cream walls, wooden counter, small accents of chocolate brown and brick red. 85mm lens, f/2, shallow depth of field, natural skin texture. Vertical 3:4 composition, waist-up framing. No text, no logos, no watermark.</a:t>
+Photorealistic editorial portrait of a 40-year-old Peruvian man, a logistics supervisor from San Miguel, Lima, middle-class. Short dark hair with a few grey strands, light stubble, friendly and practical expression, slightly hurried morning energy. He wears a simple grey polo shirt and a basic wristwatch. Early morning in a small, tidy apartment kitchen: he holds his phone in one hand (a chat app on screen, not legible) while closing a child's school lunchbox with the other. Warm morning light, cream walls, wooden counter, small accents of chocolate brown and brick red. 85mm lens, f/2, shallow depth of field, natural skin texture. Vertical 3:4 composition, waist-up framing. No text, no logos, no watermark.</a:t>
             </a:r>
             <a:endParaRPr lang="en-US" dirty="0"/>
           </a:p>
@@ -14280,7 +14280,7 @@
                   <a:schemeClr val="tx2"/>
                 </a:solidFill>
               </a:rPr>
-              <a:t>Malls de Lima Top</a:t>
+              <a:t>Malls para A y para B</a:t>
             </a:r>
             <a:endParaRPr lang="en-US" sz="1400" dirty="0"/>
           </a:p>
@@ -14294,7 +14294,7 @@
                   <a:schemeClr val="accent2"/>
                 </a:solidFill>
               </a:rPr>
-              <a:t>Jockey Plaza, Larcomar y La Rambla: programas para emprendedores</a:t>
+              <a:t>Jockey y La Rambla (A y B) · Real Plaza Salaverry y Open Plaza Angamos (B)</a:t>
             </a:r>
             <a:endParaRPr lang="en-US" sz="1400" dirty="0"/>
           </a:p>
@@ -14427,7 +14427,7 @@
                   <a:schemeClr val="accent2"/>
                 </a:solidFill>
               </a:rPr>
-              <a:t>Carrito en la entrada de Wong o Vivanda, los fines de semana</a:t>
+              <a:t>Carrito en Wong o Vivanda (A) y en Plaza Vea (B), los fines de semana</a:t>
             </a:r>
             <a:endParaRPr lang="en-US" sz="1400" dirty="0"/>
           </a:p>
@@ -14679,7 +14679,7 @@
                   <a:schemeClr val="tx2"/>
                 </a:solidFill>
               </a:rPr>
-              <a:t>Colegios y comunidad</a:t>
+              <a:t>Colegios de los dos segmentos</a:t>
             </a:r>
             <a:endParaRPr lang="en-US" sz="1400" dirty="0"/>
           </a:p>
@@ -14693,7 +14693,7 @@
                   <a:schemeClr val="accent2"/>
                 </a:solidFill>
               </a:rPr>
-              <a:t>Kermeses, cumpleaños, ferias saludables y quioscos</a:t>
+              <a:t>Quioscos y kermeses en colegios de pensión alta (A) y en cadenas como Innova Schools (B)</a:t>
             </a:r>
             <a:endParaRPr lang="en-US" sz="1400" dirty="0"/>
           </a:p>
@@ -22028,7 +22028,7 @@
                   <a:schemeClr val="tx1"/>
                 </a:solidFill>
               </a:rPr>
-              <a:t>Malls, Wong y Vivanda, ferias, quioscos y naturistas</a:t>
+              <a:t>Malls y súper para A y B, ferias, quioscos y naturistas</a:t>
             </a:r>
             <a:endParaRPr lang="en-US" sz="1200" dirty="0"/>
           </a:p>
@@ -34355,7 +34355,7 @@
                   <a:schemeClr val="tx1"/>
                 </a:solidFill>
               </a:rPr>
-              <a:t>Malls, Wong y Vivanda</a:t>
+              <a:t>Malls y súper para A y para B</a:t>
             </a:r>
             <a:endParaRPr lang="en-US" sz="1200" dirty="0"/>
           </a:p>
@@ -35429,7 +35429,7 @@
                   <a:schemeClr val="tx1"/>
                 </a:solidFill>
               </a:rPr>
-              <a:t>Padres A/B de 32 a 45 años que leen etiquetas</a:t>
+              <a:t>Padres A y B de 32 a 45 que leen etiquetas (7 de cada 10, B)</a:t>
             </a:r>
             <a:endParaRPr lang="en-US" sz="1200" dirty="0"/>
           </a:p>
@@ -49959,8 +49959,8 @@
         </p:nvSpPr>
         <p:spPr>
           <a:xfrm>
-            <a:off x="868680" y="2971800"/>
-            <a:ext cx="4572000" cy="2011680"/>
+            <a:off x="868680" y="2880360"/>
+            <a:ext cx="4572000" cy="2377440"/>
           </a:xfrm>
           <a:prstGeom prst="rect">
             <a:avLst/>
@@ -49974,7 +49974,7 @@
           <a:p>
             <a:pPr marL="342900" indent="-342900">
               <a:spcAft>
-                <a:spcPts val="800"/>
+                <a:spcPts val="600"/>
               </a:spcAft>
               <a:buSzPct val="100000"/>
               <a:buChar char="•"/>
@@ -49992,7 +49992,7 @@
           <a:p>
             <a:pPr marL="342900" indent="-342900">
               <a:spcAft>
-                <a:spcPts val="800"/>
+                <a:spcPts val="600"/>
               </a:spcAft>
               <a:buSzPct val="100000"/>
               <a:buChar char="•"/>
@@ -50003,14 +50003,14 @@
                   <a:schemeClr val="tx1"/>
                 </a:solidFill>
               </a:rPr>
-              <a:t>NSE A y B de Lima Top y Lima Moderna</a:t>
+              <a:t>NSE A y B: 7 de cada 10 hogares son B</a:t>
             </a:r>
             <a:endParaRPr lang="en-US" sz="1600" dirty="0"/>
           </a:p>
           <a:p>
             <a:pPr marL="342900" indent="-342900">
               <a:spcAft>
-                <a:spcPts val="800"/>
+                <a:spcPts val="600"/>
               </a:spcAft>
               <a:buSzPct val="100000"/>
               <a:buChar char="•"/>
@@ -50021,14 +50021,32 @@
                   <a:schemeClr val="tx1"/>
                 </a:solidFill>
               </a:rPr>
-              <a:t>Hijos de 4 a 11 en colegio privado</a:t>
+              <a:t>Viven en Lima Top y Lima Moderna</a:t>
             </a:r>
             <a:endParaRPr lang="en-US" sz="1600" dirty="0"/>
           </a:p>
           <a:p>
             <a:pPr marL="342900" indent="-342900">
               <a:spcAft>
-                <a:spcPts val="800"/>
+                <a:spcPts val="600"/>
+              </a:spcAft>
+              <a:buSzPct val="100000"/>
+              <a:buChar char="•"/>
+            </a:pPr>
+            <a:r>
+              <a:rPr lang="en-US" sz="1600" dirty="0">
+                <a:solidFill>
+                  <a:schemeClr val="tx1"/>
+                </a:solidFill>
+              </a:rPr>
+              <a:t>Hijos de 4 a 11 en colegio privado</a:t>
+            </a:r>
+            <a:endParaRPr lang="en-US" sz="1600" dirty="0"/>
+          </a:p>
+          <a:p>
+            <a:pPr marL="342900" indent="-342900">
+              <a:spcAft>
+                <a:spcPts val="600"/>
               </a:spcAft>
               <a:buSzPct val="100000"/>
               <a:buChar char="•"/>
@@ -51364,7 +51382,7 @@
                   <a:schemeClr val="accent2"/>
                 </a:solidFill>
               </a:rPr>
-              <a:t>Papá o mamá de 38 a 45, gerente</a:t>
+              <a:t>Papá o mamá de 36 a 45, mando medio</a:t>
             </a:r>
             <a:endParaRPr lang="en-US" sz="1200" dirty="0"/>
           </a:p>
@@ -51580,7 +51598,7 @@
                   <a:schemeClr val="tx1"/>
                 </a:solidFill>
               </a:rPr>
-              <a:t>Rapidez y practicidad</a:t>
+              <a:t>Que valga lo que cuesta</a:t>
             </a:r>
             <a:endParaRPr lang="en-US" sz="1500" dirty="0"/>
           </a:p>
@@ -51652,7 +51670,7 @@
                   <a:schemeClr val="tx1"/>
                 </a:solidFill>
               </a:rPr>
-              <a:t>Supermercado y WhatsApp</a:t>
+              <a:t>Plaza Vea, Tottus y WhatsApp</a:t>
             </a:r>
             <a:endParaRPr lang="en-US" sz="1500" dirty="0"/>
           </a:p>
@@ -52429,7 +52447,7 @@
                   <a:schemeClr val="accent1"/>
                 </a:solidFill>
               </a:rPr>
-              <a:t>TRABAJO DE CAMPO 5 · BUYER PERSONA PRINCIPAL</a:t>
+              <a:t>TRABAJO DE CAMPO 5 · BUYER PERSONA · SEGMENTO A</a:t>
             </a:r>
             <a:endParaRPr lang="en-US" sz="1200" dirty="0"/>
           </a:p>
@@ -53779,7 +53797,7 @@
                   <a:schemeClr val="accent1"/>
                 </a:solidFill>
               </a:rPr>
-              <a:t>TRABAJO DE CAMPO 5 · BUYER PERSONA SECUNDARIO</a:t>
+              <a:t>TRABAJO DE CAMPO 5 · BUYER PERSONA · SEGMENTO B</a:t>
             </a:r>
             <a:endParaRPr lang="en-US" sz="1200" dirty="0"/>
           </a:p>
@@ -53918,7 +53936,7 @@
                   <a:schemeClr val="accent2"/>
                 </a:solidFill>
               </a:rPr>
-              <a:t>Retrato de Rodrigo (42, La Molina)</a:t>
+              <a:t>Retrato de Rodrigo (40, San Miguel)</a:t>
             </a:r>
             <a:endParaRPr lang="en-US" sz="1400" dirty="0"/>
           </a:p>
@@ -54074,7 +54092,7 @@
                   <a:schemeClr val="tx2"/>
                 </a:solidFill>
               </a:rPr>
-              <a:t>42 años · La Molina</a:t>
+              <a:t>40 años · San Miguel</a:t>
             </a:r>
             <a:endParaRPr lang="en-US" sz="1500" dirty="0"/>
           </a:p>
@@ -54180,7 +54198,7 @@
                   <a:schemeClr val="tx2"/>
                 </a:solidFill>
               </a:rPr>
-              <a:t>Gerente de operaciones</a:t>
+              <a:t>Jefe de logística</a:t>
             </a:r>
             <a:endParaRPr lang="en-US" sz="1500" dirty="0"/>
           </a:p>
@@ -54392,7 +54410,7 @@
                   <a:schemeClr val="tx2"/>
                 </a:solidFill>
               </a:rPr>
-              <a:t>S/18,000 al mes</a:t>
+              <a:t>S/8,500 al mes</a:t>
             </a:r>
             <a:endParaRPr lang="en-US" sz="1500" dirty="0"/>
           </a:p>
@@ -54498,7 +54516,7 @@
                   <a:schemeClr val="tx2"/>
                 </a:solidFill>
               </a:rPr>
-              <a:t>Apps, IG y TikTok</a:t>
+              <a:t>Plaza Vea y WhatsApp</a:t>
             </a:r>
             <a:endParaRPr lang="en-US" sz="1500" dirty="0"/>
           </a:p>
@@ -54781,7 +54799,7 @@
                   <a:schemeClr val="tx1"/>
                 </a:solidFill>
               </a:rPr>
-              <a:t>Snacks aplastados en la mochila</a:t>
+              <a:t>Que no le rinda el dinero</a:t>
             </a:r>
             <a:endParaRPr lang="en-US" sz="1400" dirty="0"/>
           </a:p>
@@ -54958,7 +54976,7 @@
                   <a:schemeClr val="tx1"/>
                 </a:solidFill>
               </a:rPr>
-              <a:t>Recordatorio para recomprar</a:t>
+              <a:t>Precio claro por brownie</a:t>
             </a:r>
             <a:endParaRPr lang="en-US" sz="1400" dirty="0"/>
           </a:p>

</xml_diff>

<commit_message>
Actividades clave: el costo de calidad ya no parece sumarse dos veces
Co-Authored-By: Claude Opus 5.5 <noreply@anthropic.com>
Claude-Session: https://claude.ai/code/session_01Kfbf7cfV7pXUcNjjyaPCzV
</commit_message>
<xml_diff>
--- a/04-reformulacion/TC5-8/TC5-8-AndiBite.pptx
+++ b/04-reformulacion/TC5-8/TC5-8-AndiBite.pptx
@@ -142,13 +142,13 @@
   <p:extLst>
     <p:ext uri="{521415D9-36F7-43E2-AB2F-B90AF26B5E84}">
       <p14:sectionLst xmlns:p14="http://schemas.microsoft.com/office/powerpoint/2010/main">
-        <p14:section name="Portada" id="{9f06238e-bae5-77e5-bbb9-fbbed74f096b}">
+        <p14:section name="Portada" id="{6bb93df4-7275-e5c1-2d84-0ff037ea38f7}">
           <p14:sldIdLst>
             <p14:sldId id="256"/>
             <p14:sldId id="257"/>
           </p14:sldIdLst>
         </p14:section>
-        <p14:section name="TC5 · Cliente, mercado y canal" id="{76ca459e-9410-98a4-c60e-0c7d210f1868}">
+        <p14:section name="TC5 · Cliente, mercado y canal" id="{b00ad03c-17f6-3167-3f80-477b4c79be9b}">
           <p14:sldIdLst>
             <p14:sldId id="258"/>
             <p14:sldId id="259"/>
@@ -162,7 +162,7 @@
             <p14:sldId id="267"/>
           </p14:sldIdLst>
         </p14:section>
-        <p14:section name="TC6 · Relación e ingresos" id="{e56c48f2-4a9d-c768-94e3-f752d3fd75ed}">
+        <p14:section name="TC6 · Relación e ingresos" id="{fc878a28-b38b-bb02-57a6-09f127f28760}">
           <p14:sldIdLst>
             <p14:sldId id="268"/>
             <p14:sldId id="269"/>
@@ -171,7 +171,7 @@
             <p14:sldId id="272"/>
           </p14:sldIdLst>
         </p14:section>
-        <p14:section name="TC7 · Canvas" id="{78d57c94-d486-6f97-9ae1-e924219b8c6d}">
+        <p14:section name="TC7 · Canvas" id="{0c6f888e-f448-36cc-49f6-15efc1b790b3}">
           <p14:sldIdLst>
             <p14:sldId id="273"/>
             <p14:sldId id="274"/>
@@ -185,7 +185,7 @@
             <p14:sldId id="282"/>
           </p14:sldIdLst>
         </p14:section>
-        <p14:section name="TC8 · Propuesta de valor" id="{dd8e6ed5-dab8-70cb-d3ae-a259cf5b9074}">
+        <p14:section name="TC8 · Propuesta de valor" id="{9df8ab34-5dfa-8806-6883-d8d2401cb831}">
           <p14:sldIdLst>
             <p14:sldId id="283"/>
             <p14:sldId id="284"/>
@@ -196,7 +196,7 @@
             <p14:sldId id="289"/>
           </p14:sldIdLst>
         </p14:section>
-        <p14:section name="Cierre" id="{609ce8b3-dd19-989b-dadc-0a2601b7ce1e}">
+        <p14:section name="Cierre" id="{b64aaca4-f7e6-fa7e-deab-ab4296f83090}">
           <p14:sldIdLst>
             <p14:sldId id="290"/>
             <p14:sldId id="291"/>
@@ -6648,7 +6648,7 @@
           <a:p>
             <a:r>
               <a:rPr lang="en-US" dirty="0"/>
-              <a:t>Sesión 08: toda actividad genera un costo. Tipos de actividad de Osterwalder, en palabras simples: producción, atender al cliente (en el libro, "resolución de problemas"), mantener canales (en el libro, "plataforma") y gestión. Producir cuesta S/1.64 por brownie en el pack de 6, todo incluido: fabricar S/1.06 (S/0.605 de insumos con sangrecita de res en polvo a S/300 por kg, y S/0.45 que nos cobra la planta) más S/0.58 de bolsita, doypack, etiquetas con el código de la app, calidad, transporte, almacén y merma. La calidad cuesta S/625 por la producción de cada mes (microbiológico S/250 y hierro S/375, que se publica en la app); el hierro se mide todos los meses hasta junio y cada 2 meses desde julio, cuando la receta ya es estable: en promedio S/0.12 por brownie. Vender en stands: S/600 por punto al mes y S/90 por día de vendedor(a). Ferias pagadas: S/1,800 de stand más 3 días de vendedor(a) (S/270); cada evento sin costo, S/90 de vendedor(a) y S/70 de aporte al organizador. Recompra: S/0.50 por brownie con entregas agrupadas 2 días por semana por zona y recojo en el stand. Contenido: S/700 de pauta y material, y S/200 para premiar a las mamás embajadoras. App: S/250 al mes de servidor y mantenimiento, más S/0.04 por código impreso. Administración: S/745 (contador, facturación, web, teléfono, movilidad, GS1, banco y uniformes) y la coordinadora en planilla, S/709. El carné de sanidad es requisito al contratar, así que no lo paga la empresa.</a:t>
+              <a:t>Sesión 08: toda actividad genera un costo. Tipos de actividad de Osterwalder, en palabras simples: producción, atender al cliente (en el libro, "resolución de problemas"), mantener canales (en el libro, "plataforma") y gestión. Producir cuesta S/1.64 por brownie en el pack de 6, todo incluido: fabricar S/1.06 (S/0.605 de insumos con sangrecita de res en polvo a S/300 por kg, y S/0.45 que nos cobra la planta) más S/0.30 de empaque (bolsita, doypack y etiquetas con el código de la app), S/0.16 de merma, transporte y almacén, y S/0.12 de calidad. Esos S/0.12 son el análisis de cada mes, que se muestra en la segunda fila solo para explicar de dónde salen: no se suman dos veces. La calidad cuesta S/625 por la producción de cada mes (microbiológico S/250 y hierro S/375, que se publica en la app); el hierro se mide todos los meses hasta junio y cada 2 meses desde julio, cuando la receta ya es estable: en promedio S/0.12 por brownie. Vender en stands: S/600 por punto al mes y S/90 por día de vendedor(a). Ferias pagadas: S/1,800 de stand más 3 días de vendedor(a) (S/270); cada evento sin costo, S/90 de vendedor(a) y S/70 de aporte al organizador. Recompra: S/0.50 por brownie con entregas agrupadas 2 días por semana por zona y recojo en el stand. Contenido: S/700 de pauta y material, y S/200 para premiar a las mamás embajadoras. App: S/250 al mes de servidor y mantenimiento, más S/0.04 por código impreso. Administración: S/745 (contador, facturación, web, teléfono, movilidad, GS1, banco y uniformes) y la coordinadora en planilla, S/709. El carné de sanidad es requisito al contratar, así que no lo paga la empresa.</a:t>
             </a:r>
             <a:endParaRPr lang="en-US" dirty="0"/>
           </a:p>
@@ -26524,7 +26524,7 @@
                 <a:gridCol w="4343400"/>
                 <a:gridCol w="1719072"/>
               </a:tblGrid>
-              <a:tr h="457200">
+              <a:tr h="420624">
                 <a:tc>
                   <a:txBody>
                     <a:bodyPr/>
@@ -26770,7 +26770,7 @@
                   </a:tcPr>
                 </a:tc>
               </a:tr>
-              <a:tr h="457200">
+              <a:tr h="585216">
                 <a:tc>
                   <a:txBody>
                     <a:bodyPr/>
@@ -26907,7 +26907,7 @@
                             <a:schemeClr val="tx1"/>
                           </a:solidFill>
                         </a:rPr>
-                        <a:t>S/1.64 por brownie todo incluido (fabricar S/1.06 + empaque y calidad S/0.58)</a:t>
+                        <a:t>S/1.64 por brownie: fabricar S/1.06 + empaque S/0.30 + merma y traslado S/0.16 + calidad S/0.12</a:t>
                       </a:r>
                       <a:endParaRPr lang="en-US" sz="1300" dirty="0"/>
                     </a:p>
@@ -27016,7 +27016,7 @@
                   </a:tcPr>
                 </a:tc>
               </a:tr>
-              <a:tr h="457200">
+              <a:tr h="585216">
                 <a:tc>
                   <a:txBody>
                     <a:bodyPr/>
@@ -27153,7 +27153,745 @@
                             <a:schemeClr val="tx1"/>
                           </a:solidFill>
                         </a:rPr>
-                        <a:t>S/625 por la producción de cada mes (S/0.12 por brownie)</a:t>
+                        <a:t>S/625 por la producción de cada mes: son los S/0.12 de la fila de arriba</a:t>
+                      </a:r>
+                      <a:endParaRPr lang="en-US" sz="1300" dirty="0"/>
+                    </a:p>
+                  </a:txBody>
+                  <a:tcPr marL="64008" marR="64008" marT="64008" marB="64008" anchor="ctr">
+                    <a:lnL w="9525" cap="flat" cmpd="sng" algn="ctr">
+                      <a:solidFill>
+                        <a:srgbClr val="E8D8C4"/>
+                      </a:solidFill>
+                      <a:prstDash val="solid"/>
+                      <a:round/>
+                      <a:headEnd type="none" w="med" len="med"/>
+                      <a:tailEnd type="none" w="med" len="med"/>
+                    </a:lnL>
+                    <a:lnR w="9525" cap="flat" cmpd="sng" algn="ctr">
+                      <a:solidFill>
+                        <a:srgbClr val="E8D8C4"/>
+                      </a:solidFill>
+                      <a:prstDash val="solid"/>
+                      <a:round/>
+                      <a:headEnd type="none" w="med" len="med"/>
+                      <a:tailEnd type="none" w="med" len="med"/>
+                    </a:lnR>
+                    <a:lnT w="9525" cap="flat" cmpd="sng" algn="ctr">
+                      <a:solidFill>
+                        <a:srgbClr val="E8D8C4"/>
+                      </a:solidFill>
+                      <a:prstDash val="solid"/>
+                      <a:round/>
+                      <a:headEnd type="none" w="med" len="med"/>
+                      <a:tailEnd type="none" w="med" len="med"/>
+                    </a:lnT>
+                    <a:lnB w="9525" cap="flat" cmpd="sng" algn="ctr">
+                      <a:solidFill>
+                        <a:srgbClr val="E8D8C4"/>
+                      </a:solidFill>
+                      <a:prstDash val="solid"/>
+                      <a:round/>
+                      <a:headEnd type="none" w="med" len="med"/>
+                      <a:tailEnd type="none" w="med" len="med"/>
+                    </a:lnB>
+                    <a:solidFill>
+                      <a:srgbClr val="FFFFFF"/>
+                    </a:solidFill>
+                  </a:tcPr>
+                </a:tc>
+                <a:tc>
+                  <a:txBody>
+                    <a:bodyPr/>
+                    <a:lstStyle/>
+                    <a:p>
+                      <a:pPr indent="0" marL="0">
+                        <a:buNone/>
+                      </a:pPr>
+                      <a:r>
+                        <a:rPr lang="en-US" sz="1200" dirty="0">
+                          <a:solidFill>
+                            <a:schemeClr val="accent2"/>
+                          </a:solidFill>
+                        </a:rPr>
+                        <a:t>Ya incluido arriba</a:t>
+                      </a:r>
+                      <a:endParaRPr lang="en-US" sz="1200" dirty="0"/>
+                    </a:p>
+                  </a:txBody>
+                  <a:tcPr marL="64008" marR="64008" marT="64008" marB="64008" anchor="ctr">
+                    <a:lnL w="9525" cap="flat" cmpd="sng" algn="ctr">
+                      <a:solidFill>
+                        <a:srgbClr val="E8D8C4"/>
+                      </a:solidFill>
+                      <a:prstDash val="solid"/>
+                      <a:round/>
+                      <a:headEnd type="none" w="med" len="med"/>
+                      <a:tailEnd type="none" w="med" len="med"/>
+                    </a:lnL>
+                    <a:lnR w="9525" cap="flat" cmpd="sng" algn="ctr">
+                      <a:solidFill>
+                        <a:srgbClr val="E8D8C4"/>
+                      </a:solidFill>
+                      <a:prstDash val="solid"/>
+                      <a:round/>
+                      <a:headEnd type="none" w="med" len="med"/>
+                      <a:tailEnd type="none" w="med" len="med"/>
+                    </a:lnR>
+                    <a:lnT w="9525" cap="flat" cmpd="sng" algn="ctr">
+                      <a:solidFill>
+                        <a:srgbClr val="E8D8C4"/>
+                      </a:solidFill>
+                      <a:prstDash val="solid"/>
+                      <a:round/>
+                      <a:headEnd type="none" w="med" len="med"/>
+                      <a:tailEnd type="none" w="med" len="med"/>
+                    </a:lnT>
+                    <a:lnB w="9525" cap="flat" cmpd="sng" algn="ctr">
+                      <a:solidFill>
+                        <a:srgbClr val="E8D8C4"/>
+                      </a:solidFill>
+                      <a:prstDash val="solid"/>
+                      <a:round/>
+                      <a:headEnd type="none" w="med" len="med"/>
+                      <a:tailEnd type="none" w="med" len="med"/>
+                    </a:lnB>
+                    <a:solidFill>
+                      <a:srgbClr val="FFFFFF"/>
+                    </a:solidFill>
+                  </a:tcPr>
+                </a:tc>
+              </a:tr>
+              <a:tr h="438912">
+                <a:tc>
+                  <a:txBody>
+                    <a:bodyPr/>
+                    <a:lstStyle/>
+                    <a:p>
+                      <a:pPr indent="0" marL="0">
+                        <a:buNone/>
+                      </a:pPr>
+                      <a:r>
+                        <a:rPr lang="en-US" sz="1300" b="1" dirty="0">
+                          <a:solidFill>
+                            <a:schemeClr val="tx1"/>
+                          </a:solidFill>
+                        </a:rPr>
+                        <a:t>Vender en stands y carrito</a:t>
+                      </a:r>
+                      <a:endParaRPr lang="en-US" sz="1300" dirty="0"/>
+                    </a:p>
+                  </a:txBody>
+                  <a:tcPr marL="64008" marR="64008" marT="64008" marB="64008" anchor="ctr">
+                    <a:lnL w="9525" cap="flat" cmpd="sng" algn="ctr">
+                      <a:solidFill>
+                        <a:srgbClr val="E8D8C4"/>
+                      </a:solidFill>
+                      <a:prstDash val="solid"/>
+                      <a:round/>
+                      <a:headEnd type="none" w="med" len="med"/>
+                      <a:tailEnd type="none" w="med" len="med"/>
+                    </a:lnL>
+                    <a:lnR w="9525" cap="flat" cmpd="sng" algn="ctr">
+                      <a:solidFill>
+                        <a:srgbClr val="E8D8C4"/>
+                      </a:solidFill>
+                      <a:prstDash val="solid"/>
+                      <a:round/>
+                      <a:headEnd type="none" w="med" len="med"/>
+                      <a:tailEnd type="none" w="med" len="med"/>
+                    </a:lnR>
+                    <a:lnT w="9525" cap="flat" cmpd="sng" algn="ctr">
+                      <a:solidFill>
+                        <a:srgbClr val="E8D8C4"/>
+                      </a:solidFill>
+                      <a:prstDash val="solid"/>
+                      <a:round/>
+                      <a:headEnd type="none" w="med" len="med"/>
+                      <a:tailEnd type="none" w="med" len="med"/>
+                    </a:lnT>
+                    <a:lnB w="9525" cap="flat" cmpd="sng" algn="ctr">
+                      <a:solidFill>
+                        <a:srgbClr val="E8D8C4"/>
+                      </a:solidFill>
+                      <a:prstDash val="solid"/>
+                      <a:round/>
+                      <a:headEnd type="none" w="med" len="med"/>
+                      <a:tailEnd type="none" w="med" len="med"/>
+                    </a:lnB>
+                    <a:solidFill>
+                      <a:srgbClr val="FFFFFF"/>
+                    </a:solidFill>
+                  </a:tcPr>
+                </a:tc>
+                <a:tc>
+                  <a:txBody>
+                    <a:bodyPr/>
+                    <a:lstStyle/>
+                    <a:p>
+                      <a:pPr indent="0" marL="0">
+                        <a:buNone/>
+                      </a:pPr>
+                      <a:r>
+                        <a:rPr lang="en-US" sz="1200" b="1" dirty="0">
+                          <a:solidFill>
+                            <a:schemeClr val="accent1"/>
+                          </a:solidFill>
+                        </a:rPr>
+                        <a:t>Atender al cliente</a:t>
+                      </a:r>
+                      <a:endParaRPr lang="en-US" sz="1200" dirty="0"/>
+                    </a:p>
+                  </a:txBody>
+                  <a:tcPr marL="64008" marR="64008" marT="64008" marB="64008" anchor="ctr">
+                    <a:lnL w="9525" cap="flat" cmpd="sng" algn="ctr">
+                      <a:solidFill>
+                        <a:srgbClr val="E8D8C4"/>
+                      </a:solidFill>
+                      <a:prstDash val="solid"/>
+                      <a:round/>
+                      <a:headEnd type="none" w="med" len="med"/>
+                      <a:tailEnd type="none" w="med" len="med"/>
+                    </a:lnL>
+                    <a:lnR w="9525" cap="flat" cmpd="sng" algn="ctr">
+                      <a:solidFill>
+                        <a:srgbClr val="E8D8C4"/>
+                      </a:solidFill>
+                      <a:prstDash val="solid"/>
+                      <a:round/>
+                      <a:headEnd type="none" w="med" len="med"/>
+                      <a:tailEnd type="none" w="med" len="med"/>
+                    </a:lnR>
+                    <a:lnT w="9525" cap="flat" cmpd="sng" algn="ctr">
+                      <a:solidFill>
+                        <a:srgbClr val="E8D8C4"/>
+                      </a:solidFill>
+                      <a:prstDash val="solid"/>
+                      <a:round/>
+                      <a:headEnd type="none" w="med" len="med"/>
+                      <a:tailEnd type="none" w="med" len="med"/>
+                    </a:lnT>
+                    <a:lnB w="9525" cap="flat" cmpd="sng" algn="ctr">
+                      <a:solidFill>
+                        <a:srgbClr val="E8D8C4"/>
+                      </a:solidFill>
+                      <a:prstDash val="solid"/>
+                      <a:round/>
+                      <a:headEnd type="none" w="med" len="med"/>
+                      <a:tailEnd type="none" w="med" len="med"/>
+                    </a:lnB>
+                    <a:solidFill>
+                      <a:srgbClr val="FFFFFF"/>
+                    </a:solidFill>
+                  </a:tcPr>
+                </a:tc>
+                <a:tc>
+                  <a:txBody>
+                    <a:bodyPr/>
+                    <a:lstStyle/>
+                    <a:p>
+                      <a:pPr indent="0" marL="0">
+                        <a:buNone/>
+                      </a:pPr>
+                      <a:r>
+                        <a:rPr lang="en-US" sz="1300" dirty="0">
+                          <a:solidFill>
+                            <a:schemeClr val="tx1"/>
+                          </a:solidFill>
+                        </a:rPr>
+                        <a:t>S/600 por punto al mes + S/90 por día de vendedor(a)</a:t>
+                      </a:r>
+                      <a:endParaRPr lang="en-US" sz="1300" dirty="0"/>
+                    </a:p>
+                  </a:txBody>
+                  <a:tcPr marL="64008" marR="64008" marT="64008" marB="64008" anchor="ctr">
+                    <a:lnL w="9525" cap="flat" cmpd="sng" algn="ctr">
+                      <a:solidFill>
+                        <a:srgbClr val="E8D8C4"/>
+                      </a:solidFill>
+                      <a:prstDash val="solid"/>
+                      <a:round/>
+                      <a:headEnd type="none" w="med" len="med"/>
+                      <a:tailEnd type="none" w="med" len="med"/>
+                    </a:lnL>
+                    <a:lnR w="9525" cap="flat" cmpd="sng" algn="ctr">
+                      <a:solidFill>
+                        <a:srgbClr val="E8D8C4"/>
+                      </a:solidFill>
+                      <a:prstDash val="solid"/>
+                      <a:round/>
+                      <a:headEnd type="none" w="med" len="med"/>
+                      <a:tailEnd type="none" w="med" len="med"/>
+                    </a:lnR>
+                    <a:lnT w="9525" cap="flat" cmpd="sng" algn="ctr">
+                      <a:solidFill>
+                        <a:srgbClr val="E8D8C4"/>
+                      </a:solidFill>
+                      <a:prstDash val="solid"/>
+                      <a:round/>
+                      <a:headEnd type="none" w="med" len="med"/>
+                      <a:tailEnd type="none" w="med" len="med"/>
+                    </a:lnT>
+                    <a:lnB w="9525" cap="flat" cmpd="sng" algn="ctr">
+                      <a:solidFill>
+                        <a:srgbClr val="E8D8C4"/>
+                      </a:solidFill>
+                      <a:prstDash val="solid"/>
+                      <a:round/>
+                      <a:headEnd type="none" w="med" len="med"/>
+                      <a:tailEnd type="none" w="med" len="med"/>
+                    </a:lnB>
+                    <a:solidFill>
+                      <a:srgbClr val="FFFFFF"/>
+                    </a:solidFill>
+                  </a:tcPr>
+                </a:tc>
+                <a:tc>
+                  <a:txBody>
+                    <a:bodyPr/>
+                    <a:lstStyle/>
+                    <a:p>
+                      <a:pPr indent="0" marL="0">
+                        <a:buNone/>
+                      </a:pPr>
+                      <a:r>
+                        <a:rPr lang="en-US" sz="1200" dirty="0">
+                          <a:solidFill>
+                            <a:schemeClr val="accent2"/>
+                          </a:solidFill>
+                        </a:rPr>
+                        <a:t>Crece con cada punto</a:t>
+                      </a:r>
+                      <a:endParaRPr lang="en-US" sz="1200" dirty="0"/>
+                    </a:p>
+                  </a:txBody>
+                  <a:tcPr marL="64008" marR="64008" marT="64008" marB="64008" anchor="ctr">
+                    <a:lnL w="9525" cap="flat" cmpd="sng" algn="ctr">
+                      <a:solidFill>
+                        <a:srgbClr val="E8D8C4"/>
+                      </a:solidFill>
+                      <a:prstDash val="solid"/>
+                      <a:round/>
+                      <a:headEnd type="none" w="med" len="med"/>
+                      <a:tailEnd type="none" w="med" len="med"/>
+                    </a:lnL>
+                    <a:lnR w="9525" cap="flat" cmpd="sng" algn="ctr">
+                      <a:solidFill>
+                        <a:srgbClr val="E8D8C4"/>
+                      </a:solidFill>
+                      <a:prstDash val="solid"/>
+                      <a:round/>
+                      <a:headEnd type="none" w="med" len="med"/>
+                      <a:tailEnd type="none" w="med" len="med"/>
+                    </a:lnR>
+                    <a:lnT w="9525" cap="flat" cmpd="sng" algn="ctr">
+                      <a:solidFill>
+                        <a:srgbClr val="E8D8C4"/>
+                      </a:solidFill>
+                      <a:prstDash val="solid"/>
+                      <a:round/>
+                      <a:headEnd type="none" w="med" len="med"/>
+                      <a:tailEnd type="none" w="med" len="med"/>
+                    </a:lnT>
+                    <a:lnB w="9525" cap="flat" cmpd="sng" algn="ctr">
+                      <a:solidFill>
+                        <a:srgbClr val="E8D8C4"/>
+                      </a:solidFill>
+                      <a:prstDash val="solid"/>
+                      <a:round/>
+                      <a:headEnd type="none" w="med" len="med"/>
+                      <a:tailEnd type="none" w="med" len="med"/>
+                    </a:lnB>
+                    <a:solidFill>
+                      <a:srgbClr val="FBF3E8"/>
+                    </a:solidFill>
+                  </a:tcPr>
+                </a:tc>
+              </a:tr>
+              <a:tr h="438912">
+                <a:tc>
+                  <a:txBody>
+                    <a:bodyPr/>
+                    <a:lstStyle/>
+                    <a:p>
+                      <a:pPr indent="0" marL="0">
+                        <a:buNone/>
+                      </a:pPr>
+                      <a:r>
+                        <a:rPr lang="en-US" sz="1300" b="1" dirty="0">
+                          <a:solidFill>
+                            <a:schemeClr val="tx1"/>
+                          </a:solidFill>
+                        </a:rPr>
+                        <a:t>Ferias y eventos</a:t>
+                      </a:r>
+                      <a:endParaRPr lang="en-US" sz="1300" dirty="0"/>
+                    </a:p>
+                  </a:txBody>
+                  <a:tcPr marL="64008" marR="64008" marT="64008" marB="64008" anchor="ctr">
+                    <a:lnL w="9525" cap="flat" cmpd="sng" algn="ctr">
+                      <a:solidFill>
+                        <a:srgbClr val="E8D8C4"/>
+                      </a:solidFill>
+                      <a:prstDash val="solid"/>
+                      <a:round/>
+                      <a:headEnd type="none" w="med" len="med"/>
+                      <a:tailEnd type="none" w="med" len="med"/>
+                    </a:lnL>
+                    <a:lnR w="9525" cap="flat" cmpd="sng" algn="ctr">
+                      <a:solidFill>
+                        <a:srgbClr val="E8D8C4"/>
+                      </a:solidFill>
+                      <a:prstDash val="solid"/>
+                      <a:round/>
+                      <a:headEnd type="none" w="med" len="med"/>
+                      <a:tailEnd type="none" w="med" len="med"/>
+                    </a:lnR>
+                    <a:lnT w="9525" cap="flat" cmpd="sng" algn="ctr">
+                      <a:solidFill>
+                        <a:srgbClr val="E8D8C4"/>
+                      </a:solidFill>
+                      <a:prstDash val="solid"/>
+                      <a:round/>
+                      <a:headEnd type="none" w="med" len="med"/>
+                      <a:tailEnd type="none" w="med" len="med"/>
+                    </a:lnT>
+                    <a:lnB w="9525" cap="flat" cmpd="sng" algn="ctr">
+                      <a:solidFill>
+                        <a:srgbClr val="E8D8C4"/>
+                      </a:solidFill>
+                      <a:prstDash val="solid"/>
+                      <a:round/>
+                      <a:headEnd type="none" w="med" len="med"/>
+                      <a:tailEnd type="none" w="med" len="med"/>
+                    </a:lnB>
+                    <a:solidFill>
+                      <a:srgbClr val="FFFFFF"/>
+                    </a:solidFill>
+                  </a:tcPr>
+                </a:tc>
+                <a:tc>
+                  <a:txBody>
+                    <a:bodyPr/>
+                    <a:lstStyle/>
+                    <a:p>
+                      <a:pPr indent="0" marL="0">
+                        <a:buNone/>
+                      </a:pPr>
+                      <a:r>
+                        <a:rPr lang="en-US" sz="1200" b="1" dirty="0">
+                          <a:solidFill>
+                            <a:schemeClr val="accent1"/>
+                          </a:solidFill>
+                        </a:rPr>
+                        <a:t>Atender al cliente</a:t>
+                      </a:r>
+                      <a:endParaRPr lang="en-US" sz="1200" dirty="0"/>
+                    </a:p>
+                  </a:txBody>
+                  <a:tcPr marL="64008" marR="64008" marT="64008" marB="64008" anchor="ctr">
+                    <a:lnL w="9525" cap="flat" cmpd="sng" algn="ctr">
+                      <a:solidFill>
+                        <a:srgbClr val="E8D8C4"/>
+                      </a:solidFill>
+                      <a:prstDash val="solid"/>
+                      <a:round/>
+                      <a:headEnd type="none" w="med" len="med"/>
+                      <a:tailEnd type="none" w="med" len="med"/>
+                    </a:lnL>
+                    <a:lnR w="9525" cap="flat" cmpd="sng" algn="ctr">
+                      <a:solidFill>
+                        <a:srgbClr val="E8D8C4"/>
+                      </a:solidFill>
+                      <a:prstDash val="solid"/>
+                      <a:round/>
+                      <a:headEnd type="none" w="med" len="med"/>
+                      <a:tailEnd type="none" w="med" len="med"/>
+                    </a:lnR>
+                    <a:lnT w="9525" cap="flat" cmpd="sng" algn="ctr">
+                      <a:solidFill>
+                        <a:srgbClr val="E8D8C4"/>
+                      </a:solidFill>
+                      <a:prstDash val="solid"/>
+                      <a:round/>
+                      <a:headEnd type="none" w="med" len="med"/>
+                      <a:tailEnd type="none" w="med" len="med"/>
+                    </a:lnT>
+                    <a:lnB w="9525" cap="flat" cmpd="sng" algn="ctr">
+                      <a:solidFill>
+                        <a:srgbClr val="E8D8C4"/>
+                      </a:solidFill>
+                      <a:prstDash val="solid"/>
+                      <a:round/>
+                      <a:headEnd type="none" w="med" len="med"/>
+                      <a:tailEnd type="none" w="med" len="med"/>
+                    </a:lnB>
+                    <a:solidFill>
+                      <a:srgbClr val="FFFFFF"/>
+                    </a:solidFill>
+                  </a:tcPr>
+                </a:tc>
+                <a:tc>
+                  <a:txBody>
+                    <a:bodyPr/>
+                    <a:lstStyle/>
+                    <a:p>
+                      <a:pPr indent="0" marL="0">
+                        <a:buNone/>
+                      </a:pPr>
+                      <a:r>
+                        <a:rPr lang="en-US" sz="1300" dirty="0">
+                          <a:solidFill>
+                            <a:schemeClr val="tx1"/>
+                          </a:solidFill>
+                        </a:rPr>
+                        <a:t>Feria S/1,800 + S/270 de vendedor(a) · evento S/160</a:t>
+                      </a:r>
+                      <a:endParaRPr lang="en-US" sz="1300" dirty="0"/>
+                    </a:p>
+                  </a:txBody>
+                  <a:tcPr marL="64008" marR="64008" marT="64008" marB="64008" anchor="ctr">
+                    <a:lnL w="9525" cap="flat" cmpd="sng" algn="ctr">
+                      <a:solidFill>
+                        <a:srgbClr val="E8D8C4"/>
+                      </a:solidFill>
+                      <a:prstDash val="solid"/>
+                      <a:round/>
+                      <a:headEnd type="none" w="med" len="med"/>
+                      <a:tailEnd type="none" w="med" len="med"/>
+                    </a:lnL>
+                    <a:lnR w="9525" cap="flat" cmpd="sng" algn="ctr">
+                      <a:solidFill>
+                        <a:srgbClr val="E8D8C4"/>
+                      </a:solidFill>
+                      <a:prstDash val="solid"/>
+                      <a:round/>
+                      <a:headEnd type="none" w="med" len="med"/>
+                      <a:tailEnd type="none" w="med" len="med"/>
+                    </a:lnR>
+                    <a:lnT w="9525" cap="flat" cmpd="sng" algn="ctr">
+                      <a:solidFill>
+                        <a:srgbClr val="E8D8C4"/>
+                      </a:solidFill>
+                      <a:prstDash val="solid"/>
+                      <a:round/>
+                      <a:headEnd type="none" w="med" len="med"/>
+                      <a:tailEnd type="none" w="med" len="med"/>
+                    </a:lnT>
+                    <a:lnB w="9525" cap="flat" cmpd="sng" algn="ctr">
+                      <a:solidFill>
+                        <a:srgbClr val="E8D8C4"/>
+                      </a:solidFill>
+                      <a:prstDash val="solid"/>
+                      <a:round/>
+                      <a:headEnd type="none" w="med" len="med"/>
+                      <a:tailEnd type="none" w="med" len="med"/>
+                    </a:lnB>
+                    <a:solidFill>
+                      <a:srgbClr val="FFFFFF"/>
+                    </a:solidFill>
+                  </a:tcPr>
+                </a:tc>
+                <a:tc>
+                  <a:txBody>
+                    <a:bodyPr/>
+                    <a:lstStyle/>
+                    <a:p>
+                      <a:pPr indent="0" marL="0">
+                        <a:buNone/>
+                      </a:pPr>
+                      <a:r>
+                        <a:rPr lang="en-US" sz="1200" dirty="0">
+                          <a:solidFill>
+                            <a:schemeClr val="accent2"/>
+                          </a:solidFill>
+                        </a:rPr>
+                        <a:t>Por evento</a:t>
+                      </a:r>
+                      <a:endParaRPr lang="en-US" sz="1200" dirty="0"/>
+                    </a:p>
+                  </a:txBody>
+                  <a:tcPr marL="64008" marR="64008" marT="64008" marB="64008" anchor="ctr">
+                    <a:lnL w="9525" cap="flat" cmpd="sng" algn="ctr">
+                      <a:solidFill>
+                        <a:srgbClr val="E8D8C4"/>
+                      </a:solidFill>
+                      <a:prstDash val="solid"/>
+                      <a:round/>
+                      <a:headEnd type="none" w="med" len="med"/>
+                      <a:tailEnd type="none" w="med" len="med"/>
+                    </a:lnL>
+                    <a:lnR w="9525" cap="flat" cmpd="sng" algn="ctr">
+                      <a:solidFill>
+                        <a:srgbClr val="E8D8C4"/>
+                      </a:solidFill>
+                      <a:prstDash val="solid"/>
+                      <a:round/>
+                      <a:headEnd type="none" w="med" len="med"/>
+                      <a:tailEnd type="none" w="med" len="med"/>
+                    </a:lnR>
+                    <a:lnT w="9525" cap="flat" cmpd="sng" algn="ctr">
+                      <a:solidFill>
+                        <a:srgbClr val="E8D8C4"/>
+                      </a:solidFill>
+                      <a:prstDash val="solid"/>
+                      <a:round/>
+                      <a:headEnd type="none" w="med" len="med"/>
+                      <a:tailEnd type="none" w="med" len="med"/>
+                    </a:lnT>
+                    <a:lnB w="9525" cap="flat" cmpd="sng" algn="ctr">
+                      <a:solidFill>
+                        <a:srgbClr val="E8D8C4"/>
+                      </a:solidFill>
+                      <a:prstDash val="solid"/>
+                      <a:round/>
+                      <a:headEnd type="none" w="med" len="med"/>
+                      <a:tailEnd type="none" w="med" len="med"/>
+                    </a:lnB>
+                    <a:solidFill>
+                      <a:srgbClr val="FFFFFF"/>
+                    </a:solidFill>
+                  </a:tcPr>
+                </a:tc>
+              </a:tr>
+              <a:tr h="438912">
+                <a:tc>
+                  <a:txBody>
+                    <a:bodyPr/>
+                    <a:lstStyle/>
+                    <a:p>
+                      <a:pPr indent="0" marL="0">
+                        <a:buNone/>
+                      </a:pPr>
+                      <a:r>
+                        <a:rPr lang="en-US" sz="1300" b="1" dirty="0">
+                          <a:solidFill>
+                            <a:schemeClr val="tx1"/>
+                          </a:solidFill>
+                        </a:rPr>
+                        <a:t>Recompra y entregas</a:t>
+                      </a:r>
+                      <a:endParaRPr lang="en-US" sz="1300" dirty="0"/>
+                    </a:p>
+                  </a:txBody>
+                  <a:tcPr marL="64008" marR="64008" marT="64008" marB="64008" anchor="ctr">
+                    <a:lnL w="9525" cap="flat" cmpd="sng" algn="ctr">
+                      <a:solidFill>
+                        <a:srgbClr val="E8D8C4"/>
+                      </a:solidFill>
+                      <a:prstDash val="solid"/>
+                      <a:round/>
+                      <a:headEnd type="none" w="med" len="med"/>
+                      <a:tailEnd type="none" w="med" len="med"/>
+                    </a:lnL>
+                    <a:lnR w="9525" cap="flat" cmpd="sng" algn="ctr">
+                      <a:solidFill>
+                        <a:srgbClr val="E8D8C4"/>
+                      </a:solidFill>
+                      <a:prstDash val="solid"/>
+                      <a:round/>
+                      <a:headEnd type="none" w="med" len="med"/>
+                      <a:tailEnd type="none" w="med" len="med"/>
+                    </a:lnR>
+                    <a:lnT w="9525" cap="flat" cmpd="sng" algn="ctr">
+                      <a:solidFill>
+                        <a:srgbClr val="E8D8C4"/>
+                      </a:solidFill>
+                      <a:prstDash val="solid"/>
+                      <a:round/>
+                      <a:headEnd type="none" w="med" len="med"/>
+                      <a:tailEnd type="none" w="med" len="med"/>
+                    </a:lnT>
+                    <a:lnB w="9525" cap="flat" cmpd="sng" algn="ctr">
+                      <a:solidFill>
+                        <a:srgbClr val="E8D8C4"/>
+                      </a:solidFill>
+                      <a:prstDash val="solid"/>
+                      <a:round/>
+                      <a:headEnd type="none" w="med" len="med"/>
+                      <a:tailEnd type="none" w="med" len="med"/>
+                    </a:lnB>
+                    <a:solidFill>
+                      <a:srgbClr val="FFFFFF"/>
+                    </a:solidFill>
+                  </a:tcPr>
+                </a:tc>
+                <a:tc>
+                  <a:txBody>
+                    <a:bodyPr/>
+                    <a:lstStyle/>
+                    <a:p>
+                      <a:pPr indent="0" marL="0">
+                        <a:buNone/>
+                      </a:pPr>
+                      <a:r>
+                        <a:rPr lang="en-US" sz="1200" b="1" dirty="0">
+                          <a:solidFill>
+                            <a:schemeClr val="accent1"/>
+                          </a:solidFill>
+                        </a:rPr>
+                        <a:t>Mantener canales</a:t>
+                      </a:r>
+                      <a:endParaRPr lang="en-US" sz="1200" dirty="0"/>
+                    </a:p>
+                  </a:txBody>
+                  <a:tcPr marL="64008" marR="64008" marT="64008" marB="64008" anchor="ctr">
+                    <a:lnL w="9525" cap="flat" cmpd="sng" algn="ctr">
+                      <a:solidFill>
+                        <a:srgbClr val="E8D8C4"/>
+                      </a:solidFill>
+                      <a:prstDash val="solid"/>
+                      <a:round/>
+                      <a:headEnd type="none" w="med" len="med"/>
+                      <a:tailEnd type="none" w="med" len="med"/>
+                    </a:lnL>
+                    <a:lnR w="9525" cap="flat" cmpd="sng" algn="ctr">
+                      <a:solidFill>
+                        <a:srgbClr val="E8D8C4"/>
+                      </a:solidFill>
+                      <a:prstDash val="solid"/>
+                      <a:round/>
+                      <a:headEnd type="none" w="med" len="med"/>
+                      <a:tailEnd type="none" w="med" len="med"/>
+                    </a:lnR>
+                    <a:lnT w="9525" cap="flat" cmpd="sng" algn="ctr">
+                      <a:solidFill>
+                        <a:srgbClr val="E8D8C4"/>
+                      </a:solidFill>
+                      <a:prstDash val="solid"/>
+                      <a:round/>
+                      <a:headEnd type="none" w="med" len="med"/>
+                      <a:tailEnd type="none" w="med" len="med"/>
+                    </a:lnT>
+                    <a:lnB w="9525" cap="flat" cmpd="sng" algn="ctr">
+                      <a:solidFill>
+                        <a:srgbClr val="E8D8C4"/>
+                      </a:solidFill>
+                      <a:prstDash val="solid"/>
+                      <a:round/>
+                      <a:headEnd type="none" w="med" len="med"/>
+                      <a:tailEnd type="none" w="med" len="med"/>
+                    </a:lnB>
+                    <a:solidFill>
+                      <a:srgbClr val="FFFFFF"/>
+                    </a:solidFill>
+                  </a:tcPr>
+                </a:tc>
+                <a:tc>
+                  <a:txBody>
+                    <a:bodyPr/>
+                    <a:lstStyle/>
+                    <a:p>
+                      <a:pPr indent="0" marL="0">
+                        <a:buNone/>
+                      </a:pPr>
+                      <a:r>
+                        <a:rPr lang="en-US" sz="1300" dirty="0">
+                          <a:solidFill>
+                            <a:schemeClr val="tx1"/>
+                          </a:solidFill>
+                        </a:rPr>
+                        <a:t>S/0.50 por brownie (entregas agrupadas por zona)</a:t>
                       </a:r>
                       <a:endParaRPr lang="en-US" sz="1300" dirty="0"/>
                     </a:p>
@@ -27257,12 +27995,12 @@
                       <a:tailEnd type="none" w="med" len="med"/>
                     </a:lnB>
                     <a:solidFill>
-                      <a:srgbClr val="FFFFFF"/>
+                      <a:srgbClr val="FBF3E8"/>
                     </a:solidFill>
                   </a:tcPr>
                 </a:tc>
               </a:tr>
-              <a:tr h="457200">
+              <a:tr h="438912">
                 <a:tc>
                   <a:txBody>
                     <a:bodyPr/>
@@ -27277,499 +28015,7 @@
                             <a:schemeClr val="tx1"/>
                           </a:solidFill>
                         </a:rPr>
-                        <a:t>Vender en stands y carrito</a:t>
-                      </a:r>
-                      <a:endParaRPr lang="en-US" sz="1300" dirty="0"/>
-                    </a:p>
-                  </a:txBody>
-                  <a:tcPr marL="64008" marR="64008" marT="64008" marB="64008" anchor="ctr">
-                    <a:lnL w="9525" cap="flat" cmpd="sng" algn="ctr">
-                      <a:solidFill>
-                        <a:srgbClr val="E8D8C4"/>
-                      </a:solidFill>
-                      <a:prstDash val="solid"/>
-                      <a:round/>
-                      <a:headEnd type="none" w="med" len="med"/>
-                      <a:tailEnd type="none" w="med" len="med"/>
-                    </a:lnL>
-                    <a:lnR w="9525" cap="flat" cmpd="sng" algn="ctr">
-                      <a:solidFill>
-                        <a:srgbClr val="E8D8C4"/>
-                      </a:solidFill>
-                      <a:prstDash val="solid"/>
-                      <a:round/>
-                      <a:headEnd type="none" w="med" len="med"/>
-                      <a:tailEnd type="none" w="med" len="med"/>
-                    </a:lnR>
-                    <a:lnT w="9525" cap="flat" cmpd="sng" algn="ctr">
-                      <a:solidFill>
-                        <a:srgbClr val="E8D8C4"/>
-                      </a:solidFill>
-                      <a:prstDash val="solid"/>
-                      <a:round/>
-                      <a:headEnd type="none" w="med" len="med"/>
-                      <a:tailEnd type="none" w="med" len="med"/>
-                    </a:lnT>
-                    <a:lnB w="9525" cap="flat" cmpd="sng" algn="ctr">
-                      <a:solidFill>
-                        <a:srgbClr val="E8D8C4"/>
-                      </a:solidFill>
-                      <a:prstDash val="solid"/>
-                      <a:round/>
-                      <a:headEnd type="none" w="med" len="med"/>
-                      <a:tailEnd type="none" w="med" len="med"/>
-                    </a:lnB>
-                    <a:solidFill>
-                      <a:srgbClr val="FFFFFF"/>
-                    </a:solidFill>
-                  </a:tcPr>
-                </a:tc>
-                <a:tc>
-                  <a:txBody>
-                    <a:bodyPr/>
-                    <a:lstStyle/>
-                    <a:p>
-                      <a:pPr indent="0" marL="0">
-                        <a:buNone/>
-                      </a:pPr>
-                      <a:r>
-                        <a:rPr lang="en-US" sz="1200" b="1" dirty="0">
-                          <a:solidFill>
-                            <a:schemeClr val="accent1"/>
-                          </a:solidFill>
-                        </a:rPr>
-                        <a:t>Atender al cliente</a:t>
-                      </a:r>
-                      <a:endParaRPr lang="en-US" sz="1200" dirty="0"/>
-                    </a:p>
-                  </a:txBody>
-                  <a:tcPr marL="64008" marR="64008" marT="64008" marB="64008" anchor="ctr">
-                    <a:lnL w="9525" cap="flat" cmpd="sng" algn="ctr">
-                      <a:solidFill>
-                        <a:srgbClr val="E8D8C4"/>
-                      </a:solidFill>
-                      <a:prstDash val="solid"/>
-                      <a:round/>
-                      <a:headEnd type="none" w="med" len="med"/>
-                      <a:tailEnd type="none" w="med" len="med"/>
-                    </a:lnL>
-                    <a:lnR w="9525" cap="flat" cmpd="sng" algn="ctr">
-                      <a:solidFill>
-                        <a:srgbClr val="E8D8C4"/>
-                      </a:solidFill>
-                      <a:prstDash val="solid"/>
-                      <a:round/>
-                      <a:headEnd type="none" w="med" len="med"/>
-                      <a:tailEnd type="none" w="med" len="med"/>
-                    </a:lnR>
-                    <a:lnT w="9525" cap="flat" cmpd="sng" algn="ctr">
-                      <a:solidFill>
-                        <a:srgbClr val="E8D8C4"/>
-                      </a:solidFill>
-                      <a:prstDash val="solid"/>
-                      <a:round/>
-                      <a:headEnd type="none" w="med" len="med"/>
-                      <a:tailEnd type="none" w="med" len="med"/>
-                    </a:lnT>
-                    <a:lnB w="9525" cap="flat" cmpd="sng" algn="ctr">
-                      <a:solidFill>
-                        <a:srgbClr val="E8D8C4"/>
-                      </a:solidFill>
-                      <a:prstDash val="solid"/>
-                      <a:round/>
-                      <a:headEnd type="none" w="med" len="med"/>
-                      <a:tailEnd type="none" w="med" len="med"/>
-                    </a:lnB>
-                    <a:solidFill>
-                      <a:srgbClr val="FFFFFF"/>
-                    </a:solidFill>
-                  </a:tcPr>
-                </a:tc>
-                <a:tc>
-                  <a:txBody>
-                    <a:bodyPr/>
-                    <a:lstStyle/>
-                    <a:p>
-                      <a:pPr indent="0" marL="0">
-                        <a:buNone/>
-                      </a:pPr>
-                      <a:r>
-                        <a:rPr lang="en-US" sz="1300" dirty="0">
-                          <a:solidFill>
-                            <a:schemeClr val="tx1"/>
-                          </a:solidFill>
-                        </a:rPr>
-                        <a:t>S/600 por punto al mes + S/90 por día de vendedor(a)</a:t>
-                      </a:r>
-                      <a:endParaRPr lang="en-US" sz="1300" dirty="0"/>
-                    </a:p>
-                  </a:txBody>
-                  <a:tcPr marL="64008" marR="64008" marT="64008" marB="64008" anchor="ctr">
-                    <a:lnL w="9525" cap="flat" cmpd="sng" algn="ctr">
-                      <a:solidFill>
-                        <a:srgbClr val="E8D8C4"/>
-                      </a:solidFill>
-                      <a:prstDash val="solid"/>
-                      <a:round/>
-                      <a:headEnd type="none" w="med" len="med"/>
-                      <a:tailEnd type="none" w="med" len="med"/>
-                    </a:lnL>
-                    <a:lnR w="9525" cap="flat" cmpd="sng" algn="ctr">
-                      <a:solidFill>
-                        <a:srgbClr val="E8D8C4"/>
-                      </a:solidFill>
-                      <a:prstDash val="solid"/>
-                      <a:round/>
-                      <a:headEnd type="none" w="med" len="med"/>
-                      <a:tailEnd type="none" w="med" len="med"/>
-                    </a:lnR>
-                    <a:lnT w="9525" cap="flat" cmpd="sng" algn="ctr">
-                      <a:solidFill>
-                        <a:srgbClr val="E8D8C4"/>
-                      </a:solidFill>
-                      <a:prstDash val="solid"/>
-                      <a:round/>
-                      <a:headEnd type="none" w="med" len="med"/>
-                      <a:tailEnd type="none" w="med" len="med"/>
-                    </a:lnT>
-                    <a:lnB w="9525" cap="flat" cmpd="sng" algn="ctr">
-                      <a:solidFill>
-                        <a:srgbClr val="E8D8C4"/>
-                      </a:solidFill>
-                      <a:prstDash val="solid"/>
-                      <a:round/>
-                      <a:headEnd type="none" w="med" len="med"/>
-                      <a:tailEnd type="none" w="med" len="med"/>
-                    </a:lnB>
-                    <a:solidFill>
-                      <a:srgbClr val="FFFFFF"/>
-                    </a:solidFill>
-                  </a:tcPr>
-                </a:tc>
-                <a:tc>
-                  <a:txBody>
-                    <a:bodyPr/>
-                    <a:lstStyle/>
-                    <a:p>
-                      <a:pPr indent="0" marL="0">
-                        <a:buNone/>
-                      </a:pPr>
-                      <a:r>
-                        <a:rPr lang="en-US" sz="1200" dirty="0">
-                          <a:solidFill>
-                            <a:schemeClr val="accent2"/>
-                          </a:solidFill>
-                        </a:rPr>
-                        <a:t>Crece con cada punto</a:t>
-                      </a:r>
-                      <a:endParaRPr lang="en-US" sz="1200" dirty="0"/>
-                    </a:p>
-                  </a:txBody>
-                  <a:tcPr marL="64008" marR="64008" marT="64008" marB="64008" anchor="ctr">
-                    <a:lnL w="9525" cap="flat" cmpd="sng" algn="ctr">
-                      <a:solidFill>
-                        <a:srgbClr val="E8D8C4"/>
-                      </a:solidFill>
-                      <a:prstDash val="solid"/>
-                      <a:round/>
-                      <a:headEnd type="none" w="med" len="med"/>
-                      <a:tailEnd type="none" w="med" len="med"/>
-                    </a:lnL>
-                    <a:lnR w="9525" cap="flat" cmpd="sng" algn="ctr">
-                      <a:solidFill>
-                        <a:srgbClr val="E8D8C4"/>
-                      </a:solidFill>
-                      <a:prstDash val="solid"/>
-                      <a:round/>
-                      <a:headEnd type="none" w="med" len="med"/>
-                      <a:tailEnd type="none" w="med" len="med"/>
-                    </a:lnR>
-                    <a:lnT w="9525" cap="flat" cmpd="sng" algn="ctr">
-                      <a:solidFill>
-                        <a:srgbClr val="E8D8C4"/>
-                      </a:solidFill>
-                      <a:prstDash val="solid"/>
-                      <a:round/>
-                      <a:headEnd type="none" w="med" len="med"/>
-                      <a:tailEnd type="none" w="med" len="med"/>
-                    </a:lnT>
-                    <a:lnB w="9525" cap="flat" cmpd="sng" algn="ctr">
-                      <a:solidFill>
-                        <a:srgbClr val="E8D8C4"/>
-                      </a:solidFill>
-                      <a:prstDash val="solid"/>
-                      <a:round/>
-                      <a:headEnd type="none" w="med" len="med"/>
-                      <a:tailEnd type="none" w="med" len="med"/>
-                    </a:lnB>
-                    <a:solidFill>
-                      <a:srgbClr val="FBF3E8"/>
-                    </a:solidFill>
-                  </a:tcPr>
-                </a:tc>
-              </a:tr>
-              <a:tr h="457200">
-                <a:tc>
-                  <a:txBody>
-                    <a:bodyPr/>
-                    <a:lstStyle/>
-                    <a:p>
-                      <a:pPr indent="0" marL="0">
-                        <a:buNone/>
-                      </a:pPr>
-                      <a:r>
-                        <a:rPr lang="en-US" sz="1300" b="1" dirty="0">
-                          <a:solidFill>
-                            <a:schemeClr val="tx1"/>
-                          </a:solidFill>
-                        </a:rPr>
-                        <a:t>Ferias y eventos</a:t>
-                      </a:r>
-                      <a:endParaRPr lang="en-US" sz="1300" dirty="0"/>
-                    </a:p>
-                  </a:txBody>
-                  <a:tcPr marL="64008" marR="64008" marT="64008" marB="64008" anchor="ctr">
-                    <a:lnL w="9525" cap="flat" cmpd="sng" algn="ctr">
-                      <a:solidFill>
-                        <a:srgbClr val="E8D8C4"/>
-                      </a:solidFill>
-                      <a:prstDash val="solid"/>
-                      <a:round/>
-                      <a:headEnd type="none" w="med" len="med"/>
-                      <a:tailEnd type="none" w="med" len="med"/>
-                    </a:lnL>
-                    <a:lnR w="9525" cap="flat" cmpd="sng" algn="ctr">
-                      <a:solidFill>
-                        <a:srgbClr val="E8D8C4"/>
-                      </a:solidFill>
-                      <a:prstDash val="solid"/>
-                      <a:round/>
-                      <a:headEnd type="none" w="med" len="med"/>
-                      <a:tailEnd type="none" w="med" len="med"/>
-                    </a:lnR>
-                    <a:lnT w="9525" cap="flat" cmpd="sng" algn="ctr">
-                      <a:solidFill>
-                        <a:srgbClr val="E8D8C4"/>
-                      </a:solidFill>
-                      <a:prstDash val="solid"/>
-                      <a:round/>
-                      <a:headEnd type="none" w="med" len="med"/>
-                      <a:tailEnd type="none" w="med" len="med"/>
-                    </a:lnT>
-                    <a:lnB w="9525" cap="flat" cmpd="sng" algn="ctr">
-                      <a:solidFill>
-                        <a:srgbClr val="E8D8C4"/>
-                      </a:solidFill>
-                      <a:prstDash val="solid"/>
-                      <a:round/>
-                      <a:headEnd type="none" w="med" len="med"/>
-                      <a:tailEnd type="none" w="med" len="med"/>
-                    </a:lnB>
-                    <a:solidFill>
-                      <a:srgbClr val="FFFFFF"/>
-                    </a:solidFill>
-                  </a:tcPr>
-                </a:tc>
-                <a:tc>
-                  <a:txBody>
-                    <a:bodyPr/>
-                    <a:lstStyle/>
-                    <a:p>
-                      <a:pPr indent="0" marL="0">
-                        <a:buNone/>
-                      </a:pPr>
-                      <a:r>
-                        <a:rPr lang="en-US" sz="1200" b="1" dirty="0">
-                          <a:solidFill>
-                            <a:schemeClr val="accent1"/>
-                          </a:solidFill>
-                        </a:rPr>
-                        <a:t>Atender al cliente</a:t>
-                      </a:r>
-                      <a:endParaRPr lang="en-US" sz="1200" dirty="0"/>
-                    </a:p>
-                  </a:txBody>
-                  <a:tcPr marL="64008" marR="64008" marT="64008" marB="64008" anchor="ctr">
-                    <a:lnL w="9525" cap="flat" cmpd="sng" algn="ctr">
-                      <a:solidFill>
-                        <a:srgbClr val="E8D8C4"/>
-                      </a:solidFill>
-                      <a:prstDash val="solid"/>
-                      <a:round/>
-                      <a:headEnd type="none" w="med" len="med"/>
-                      <a:tailEnd type="none" w="med" len="med"/>
-                    </a:lnL>
-                    <a:lnR w="9525" cap="flat" cmpd="sng" algn="ctr">
-                      <a:solidFill>
-                        <a:srgbClr val="E8D8C4"/>
-                      </a:solidFill>
-                      <a:prstDash val="solid"/>
-                      <a:round/>
-                      <a:headEnd type="none" w="med" len="med"/>
-                      <a:tailEnd type="none" w="med" len="med"/>
-                    </a:lnR>
-                    <a:lnT w="9525" cap="flat" cmpd="sng" algn="ctr">
-                      <a:solidFill>
-                        <a:srgbClr val="E8D8C4"/>
-                      </a:solidFill>
-                      <a:prstDash val="solid"/>
-                      <a:round/>
-                      <a:headEnd type="none" w="med" len="med"/>
-                      <a:tailEnd type="none" w="med" len="med"/>
-                    </a:lnT>
-                    <a:lnB w="9525" cap="flat" cmpd="sng" algn="ctr">
-                      <a:solidFill>
-                        <a:srgbClr val="E8D8C4"/>
-                      </a:solidFill>
-                      <a:prstDash val="solid"/>
-                      <a:round/>
-                      <a:headEnd type="none" w="med" len="med"/>
-                      <a:tailEnd type="none" w="med" len="med"/>
-                    </a:lnB>
-                    <a:solidFill>
-                      <a:srgbClr val="FFFFFF"/>
-                    </a:solidFill>
-                  </a:tcPr>
-                </a:tc>
-                <a:tc>
-                  <a:txBody>
-                    <a:bodyPr/>
-                    <a:lstStyle/>
-                    <a:p>
-                      <a:pPr indent="0" marL="0">
-                        <a:buNone/>
-                      </a:pPr>
-                      <a:r>
-                        <a:rPr lang="en-US" sz="1300" dirty="0">
-                          <a:solidFill>
-                            <a:schemeClr val="tx1"/>
-                          </a:solidFill>
-                        </a:rPr>
-                        <a:t>Feria S/1,800 + S/270 de vendedor(a) · evento S/160</a:t>
-                      </a:r>
-                      <a:endParaRPr lang="en-US" sz="1300" dirty="0"/>
-                    </a:p>
-                  </a:txBody>
-                  <a:tcPr marL="64008" marR="64008" marT="64008" marB="64008" anchor="ctr">
-                    <a:lnL w="9525" cap="flat" cmpd="sng" algn="ctr">
-                      <a:solidFill>
-                        <a:srgbClr val="E8D8C4"/>
-                      </a:solidFill>
-                      <a:prstDash val="solid"/>
-                      <a:round/>
-                      <a:headEnd type="none" w="med" len="med"/>
-                      <a:tailEnd type="none" w="med" len="med"/>
-                    </a:lnL>
-                    <a:lnR w="9525" cap="flat" cmpd="sng" algn="ctr">
-                      <a:solidFill>
-                        <a:srgbClr val="E8D8C4"/>
-                      </a:solidFill>
-                      <a:prstDash val="solid"/>
-                      <a:round/>
-                      <a:headEnd type="none" w="med" len="med"/>
-                      <a:tailEnd type="none" w="med" len="med"/>
-                    </a:lnR>
-                    <a:lnT w="9525" cap="flat" cmpd="sng" algn="ctr">
-                      <a:solidFill>
-                        <a:srgbClr val="E8D8C4"/>
-                      </a:solidFill>
-                      <a:prstDash val="solid"/>
-                      <a:round/>
-                      <a:headEnd type="none" w="med" len="med"/>
-                      <a:tailEnd type="none" w="med" len="med"/>
-                    </a:lnT>
-                    <a:lnB w="9525" cap="flat" cmpd="sng" algn="ctr">
-                      <a:solidFill>
-                        <a:srgbClr val="E8D8C4"/>
-                      </a:solidFill>
-                      <a:prstDash val="solid"/>
-                      <a:round/>
-                      <a:headEnd type="none" w="med" len="med"/>
-                      <a:tailEnd type="none" w="med" len="med"/>
-                    </a:lnB>
-                    <a:solidFill>
-                      <a:srgbClr val="FFFFFF"/>
-                    </a:solidFill>
-                  </a:tcPr>
-                </a:tc>
-                <a:tc>
-                  <a:txBody>
-                    <a:bodyPr/>
-                    <a:lstStyle/>
-                    <a:p>
-                      <a:pPr indent="0" marL="0">
-                        <a:buNone/>
-                      </a:pPr>
-                      <a:r>
-                        <a:rPr lang="en-US" sz="1200" dirty="0">
-                          <a:solidFill>
-                            <a:schemeClr val="accent2"/>
-                          </a:solidFill>
-                        </a:rPr>
-                        <a:t>Por evento</a:t>
-                      </a:r>
-                      <a:endParaRPr lang="en-US" sz="1200" dirty="0"/>
-                    </a:p>
-                  </a:txBody>
-                  <a:tcPr marL="64008" marR="64008" marT="64008" marB="64008" anchor="ctr">
-                    <a:lnL w="9525" cap="flat" cmpd="sng" algn="ctr">
-                      <a:solidFill>
-                        <a:srgbClr val="E8D8C4"/>
-                      </a:solidFill>
-                      <a:prstDash val="solid"/>
-                      <a:round/>
-                      <a:headEnd type="none" w="med" len="med"/>
-                      <a:tailEnd type="none" w="med" len="med"/>
-                    </a:lnL>
-                    <a:lnR w="9525" cap="flat" cmpd="sng" algn="ctr">
-                      <a:solidFill>
-                        <a:srgbClr val="E8D8C4"/>
-                      </a:solidFill>
-                      <a:prstDash val="solid"/>
-                      <a:round/>
-                      <a:headEnd type="none" w="med" len="med"/>
-                      <a:tailEnd type="none" w="med" len="med"/>
-                    </a:lnR>
-                    <a:lnT w="9525" cap="flat" cmpd="sng" algn="ctr">
-                      <a:solidFill>
-                        <a:srgbClr val="E8D8C4"/>
-                      </a:solidFill>
-                      <a:prstDash val="solid"/>
-                      <a:round/>
-                      <a:headEnd type="none" w="med" len="med"/>
-                      <a:tailEnd type="none" w="med" len="med"/>
-                    </a:lnT>
-                    <a:lnB w="9525" cap="flat" cmpd="sng" algn="ctr">
-                      <a:solidFill>
-                        <a:srgbClr val="E8D8C4"/>
-                      </a:solidFill>
-                      <a:prstDash val="solid"/>
-                      <a:round/>
-                      <a:headEnd type="none" w="med" len="med"/>
-                      <a:tailEnd type="none" w="med" len="med"/>
-                    </a:lnB>
-                    <a:solidFill>
-                      <a:srgbClr val="FFFFFF"/>
-                    </a:solidFill>
-                  </a:tcPr>
-                </a:tc>
-              </a:tr>
-              <a:tr h="457200">
-                <a:tc>
-                  <a:txBody>
-                    <a:bodyPr/>
-                    <a:lstStyle/>
-                    <a:p>
-                      <a:pPr indent="0" marL="0">
-                        <a:buNone/>
-                      </a:pPr>
-                      <a:r>
-                        <a:rPr lang="en-US" sz="1300" b="1" dirty="0">
-                          <a:solidFill>
-                            <a:schemeClr val="tx1"/>
-                          </a:solidFill>
-                        </a:rPr>
-                        <a:t>Recompra y entregas</a:t>
+                        <a:t>Contenido y mamás embajadoras</a:t>
                       </a:r>
                       <a:endParaRPr lang="en-US" sz="1300" dirty="0"/>
                     </a:p>
@@ -27891,7 +28137,7 @@
                             <a:schemeClr val="tx1"/>
                           </a:solidFill>
                         </a:rPr>
-                        <a:t>S/0.50 por brownie (entregas agrupadas por zona)</a:t>
+                        <a:t>S/700 de pauta + S/200 de embajadoras al mes</a:t>
                       </a:r>
                       <a:endParaRPr lang="en-US" sz="1300" dirty="0"/>
                     </a:p>
@@ -27952,7 +28198,7 @@
                             <a:schemeClr val="accent2"/>
                           </a:solidFill>
                         </a:rPr>
-                        <a:t>Variable</a:t>
+                        <a:t>Fijo</a:t>
                       </a:r>
                       <a:endParaRPr lang="en-US" sz="1200" dirty="0"/>
                     </a:p>
@@ -27995,12 +28241,12 @@
                       <a:tailEnd type="none" w="med" len="med"/>
                     </a:lnB>
                     <a:solidFill>
-                      <a:srgbClr val="FBF3E8"/>
+                      <a:srgbClr val="FFFFFF"/>
                     </a:solidFill>
                   </a:tcPr>
                 </a:tc>
               </a:tr>
-              <a:tr h="457200">
+              <a:tr h="438912">
                 <a:tc>
                   <a:txBody>
                     <a:bodyPr/>
@@ -28015,7 +28261,7 @@
                             <a:schemeClr val="tx1"/>
                           </a:solidFill>
                         </a:rPr>
-                        <a:t>Contenido y mamás embajadoras</a:t>
+                        <a:t>Mantener la app Andi</a:t>
                       </a:r>
                       <a:endParaRPr lang="en-US" sz="1300" dirty="0"/>
                     </a:p>
@@ -28137,7 +28383,253 @@
                             <a:schemeClr val="tx1"/>
                           </a:solidFill>
                         </a:rPr>
-                        <a:t>S/700 de pauta + S/200 de embajadoras al mes</a:t>
+                        <a:t>S/250 al mes + S/0.04 por código impreso</a:t>
+                      </a:r>
+                      <a:endParaRPr lang="en-US" sz="1300" dirty="0"/>
+                    </a:p>
+                  </a:txBody>
+                  <a:tcPr marL="64008" marR="64008" marT="64008" marB="64008" anchor="ctr">
+                    <a:lnL w="9525" cap="flat" cmpd="sng" algn="ctr">
+                      <a:solidFill>
+                        <a:srgbClr val="E8D8C4"/>
+                      </a:solidFill>
+                      <a:prstDash val="solid"/>
+                      <a:round/>
+                      <a:headEnd type="none" w="med" len="med"/>
+                      <a:tailEnd type="none" w="med" len="med"/>
+                    </a:lnL>
+                    <a:lnR w="9525" cap="flat" cmpd="sng" algn="ctr">
+                      <a:solidFill>
+                        <a:srgbClr val="E8D8C4"/>
+                      </a:solidFill>
+                      <a:prstDash val="solid"/>
+                      <a:round/>
+                      <a:headEnd type="none" w="med" len="med"/>
+                      <a:tailEnd type="none" w="med" len="med"/>
+                    </a:lnR>
+                    <a:lnT w="9525" cap="flat" cmpd="sng" algn="ctr">
+                      <a:solidFill>
+                        <a:srgbClr val="E8D8C4"/>
+                      </a:solidFill>
+                      <a:prstDash val="solid"/>
+                      <a:round/>
+                      <a:headEnd type="none" w="med" len="med"/>
+                      <a:tailEnd type="none" w="med" len="med"/>
+                    </a:lnT>
+                    <a:lnB w="9525" cap="flat" cmpd="sng" algn="ctr">
+                      <a:solidFill>
+                        <a:srgbClr val="E8D8C4"/>
+                      </a:solidFill>
+                      <a:prstDash val="solid"/>
+                      <a:round/>
+                      <a:headEnd type="none" w="med" len="med"/>
+                      <a:tailEnd type="none" w="med" len="med"/>
+                    </a:lnB>
+                    <a:solidFill>
+                      <a:srgbClr val="FFFFFF"/>
+                    </a:solidFill>
+                  </a:tcPr>
+                </a:tc>
+                <a:tc>
+                  <a:txBody>
+                    <a:bodyPr/>
+                    <a:lstStyle/>
+                    <a:p>
+                      <a:pPr indent="0" marL="0">
+                        <a:buNone/>
+                      </a:pPr>
+                      <a:r>
+                        <a:rPr lang="en-US" sz="1200" dirty="0">
+                          <a:solidFill>
+                            <a:schemeClr val="accent2"/>
+                          </a:solidFill>
+                        </a:rPr>
+                        <a:t>Fijo y variable</a:t>
+                      </a:r>
+                      <a:endParaRPr lang="en-US" sz="1200" dirty="0"/>
+                    </a:p>
+                  </a:txBody>
+                  <a:tcPr marL="64008" marR="64008" marT="64008" marB="64008" anchor="ctr">
+                    <a:lnL w="9525" cap="flat" cmpd="sng" algn="ctr">
+                      <a:solidFill>
+                        <a:srgbClr val="E8D8C4"/>
+                      </a:solidFill>
+                      <a:prstDash val="solid"/>
+                      <a:round/>
+                      <a:headEnd type="none" w="med" len="med"/>
+                      <a:tailEnd type="none" w="med" len="med"/>
+                    </a:lnL>
+                    <a:lnR w="9525" cap="flat" cmpd="sng" algn="ctr">
+                      <a:solidFill>
+                        <a:srgbClr val="E8D8C4"/>
+                      </a:solidFill>
+                      <a:prstDash val="solid"/>
+                      <a:round/>
+                      <a:headEnd type="none" w="med" len="med"/>
+                      <a:tailEnd type="none" w="med" len="med"/>
+                    </a:lnR>
+                    <a:lnT w="9525" cap="flat" cmpd="sng" algn="ctr">
+                      <a:solidFill>
+                        <a:srgbClr val="E8D8C4"/>
+                      </a:solidFill>
+                      <a:prstDash val="solid"/>
+                      <a:round/>
+                      <a:headEnd type="none" w="med" len="med"/>
+                      <a:tailEnd type="none" w="med" len="med"/>
+                    </a:lnT>
+                    <a:lnB w="9525" cap="flat" cmpd="sng" algn="ctr">
+                      <a:solidFill>
+                        <a:srgbClr val="E8D8C4"/>
+                      </a:solidFill>
+                      <a:prstDash val="solid"/>
+                      <a:round/>
+                      <a:headEnd type="none" w="med" len="med"/>
+                      <a:tailEnd type="none" w="med" len="med"/>
+                    </a:lnB>
+                    <a:solidFill>
+                      <a:srgbClr val="FBF3E8"/>
+                    </a:solidFill>
+                  </a:tcPr>
+                </a:tc>
+              </a:tr>
+              <a:tr h="438912">
+                <a:tc>
+                  <a:txBody>
+                    <a:bodyPr/>
+                    <a:lstStyle/>
+                    <a:p>
+                      <a:pPr indent="0" marL="0">
+                        <a:buNone/>
+                      </a:pPr>
+                      <a:r>
+                        <a:rPr lang="en-US" sz="1300" b="1" dirty="0">
+                          <a:solidFill>
+                            <a:schemeClr val="tx1"/>
+                          </a:solidFill>
+                        </a:rPr>
+                        <a:t>Administrar el negocio</a:t>
+                      </a:r>
+                      <a:endParaRPr lang="en-US" sz="1300" dirty="0"/>
+                    </a:p>
+                  </a:txBody>
+                  <a:tcPr marL="64008" marR="64008" marT="64008" marB="64008" anchor="ctr">
+                    <a:lnL w="9525" cap="flat" cmpd="sng" algn="ctr">
+                      <a:solidFill>
+                        <a:srgbClr val="E8D8C4"/>
+                      </a:solidFill>
+                      <a:prstDash val="solid"/>
+                      <a:round/>
+                      <a:headEnd type="none" w="med" len="med"/>
+                      <a:tailEnd type="none" w="med" len="med"/>
+                    </a:lnL>
+                    <a:lnR w="9525" cap="flat" cmpd="sng" algn="ctr">
+                      <a:solidFill>
+                        <a:srgbClr val="E8D8C4"/>
+                      </a:solidFill>
+                      <a:prstDash val="solid"/>
+                      <a:round/>
+                      <a:headEnd type="none" w="med" len="med"/>
+                      <a:tailEnd type="none" w="med" len="med"/>
+                    </a:lnR>
+                    <a:lnT w="9525" cap="flat" cmpd="sng" algn="ctr">
+                      <a:solidFill>
+                        <a:srgbClr val="E8D8C4"/>
+                      </a:solidFill>
+                      <a:prstDash val="solid"/>
+                      <a:round/>
+                      <a:headEnd type="none" w="med" len="med"/>
+                      <a:tailEnd type="none" w="med" len="med"/>
+                    </a:lnT>
+                    <a:lnB w="9525" cap="flat" cmpd="sng" algn="ctr">
+                      <a:solidFill>
+                        <a:srgbClr val="E8D8C4"/>
+                      </a:solidFill>
+                      <a:prstDash val="solid"/>
+                      <a:round/>
+                      <a:headEnd type="none" w="med" len="med"/>
+                      <a:tailEnd type="none" w="med" len="med"/>
+                    </a:lnB>
+                    <a:solidFill>
+                      <a:srgbClr val="FFFFFF"/>
+                    </a:solidFill>
+                  </a:tcPr>
+                </a:tc>
+                <a:tc>
+                  <a:txBody>
+                    <a:bodyPr/>
+                    <a:lstStyle/>
+                    <a:p>
+                      <a:pPr indent="0" marL="0">
+                        <a:buNone/>
+                      </a:pPr>
+                      <a:r>
+                        <a:rPr lang="en-US" sz="1200" b="1" dirty="0">
+                          <a:solidFill>
+                            <a:schemeClr val="accent1"/>
+                          </a:solidFill>
+                        </a:rPr>
+                        <a:t>Gestión</a:t>
+                      </a:r>
+                      <a:endParaRPr lang="en-US" sz="1200" dirty="0"/>
+                    </a:p>
+                  </a:txBody>
+                  <a:tcPr marL="64008" marR="64008" marT="64008" marB="64008" anchor="ctr">
+                    <a:lnL w="9525" cap="flat" cmpd="sng" algn="ctr">
+                      <a:solidFill>
+                        <a:srgbClr val="E8D8C4"/>
+                      </a:solidFill>
+                      <a:prstDash val="solid"/>
+                      <a:round/>
+                      <a:headEnd type="none" w="med" len="med"/>
+                      <a:tailEnd type="none" w="med" len="med"/>
+                    </a:lnL>
+                    <a:lnR w="9525" cap="flat" cmpd="sng" algn="ctr">
+                      <a:solidFill>
+                        <a:srgbClr val="E8D8C4"/>
+                      </a:solidFill>
+                      <a:prstDash val="solid"/>
+                      <a:round/>
+                      <a:headEnd type="none" w="med" len="med"/>
+                      <a:tailEnd type="none" w="med" len="med"/>
+                    </a:lnR>
+                    <a:lnT w="9525" cap="flat" cmpd="sng" algn="ctr">
+                      <a:solidFill>
+                        <a:srgbClr val="E8D8C4"/>
+                      </a:solidFill>
+                      <a:prstDash val="solid"/>
+                      <a:round/>
+                      <a:headEnd type="none" w="med" len="med"/>
+                      <a:tailEnd type="none" w="med" len="med"/>
+                    </a:lnT>
+                    <a:lnB w="9525" cap="flat" cmpd="sng" algn="ctr">
+                      <a:solidFill>
+                        <a:srgbClr val="E8D8C4"/>
+                      </a:solidFill>
+                      <a:prstDash val="solid"/>
+                      <a:round/>
+                      <a:headEnd type="none" w="med" len="med"/>
+                      <a:tailEnd type="none" w="med" len="med"/>
+                    </a:lnB>
+                    <a:solidFill>
+                      <a:srgbClr val="FFFFFF"/>
+                    </a:solidFill>
+                  </a:tcPr>
+                </a:tc>
+                <a:tc>
+                  <a:txBody>
+                    <a:bodyPr/>
+                    <a:lstStyle/>
+                    <a:p>
+                      <a:pPr indent="0" marL="0">
+                        <a:buNone/>
+                      </a:pPr>
+                      <a:r>
+                        <a:rPr lang="en-US" sz="1300" dirty="0">
+                          <a:solidFill>
+                            <a:schemeClr val="tx1"/>
+                          </a:solidFill>
+                        </a:rPr>
+                        <a:t>S/745 de administración + S/709 de la coordinadora al mes</a:t>
                       </a:r>
                       <a:endParaRPr lang="en-US" sz="1300" dirty="0"/>
                     </a:p>
@@ -28246,498 +28738,6 @@
                   </a:tcPr>
                 </a:tc>
               </a:tr>
-              <a:tr h="457200">
-                <a:tc>
-                  <a:txBody>
-                    <a:bodyPr/>
-                    <a:lstStyle/>
-                    <a:p>
-                      <a:pPr indent="0" marL="0">
-                        <a:buNone/>
-                      </a:pPr>
-                      <a:r>
-                        <a:rPr lang="en-US" sz="1300" b="1" dirty="0">
-                          <a:solidFill>
-                            <a:schemeClr val="tx1"/>
-                          </a:solidFill>
-                        </a:rPr>
-                        <a:t>Mantener la app Andi</a:t>
-                      </a:r>
-                      <a:endParaRPr lang="en-US" sz="1300" dirty="0"/>
-                    </a:p>
-                  </a:txBody>
-                  <a:tcPr marL="64008" marR="64008" marT="64008" marB="64008" anchor="ctr">
-                    <a:lnL w="9525" cap="flat" cmpd="sng" algn="ctr">
-                      <a:solidFill>
-                        <a:srgbClr val="E8D8C4"/>
-                      </a:solidFill>
-                      <a:prstDash val="solid"/>
-                      <a:round/>
-                      <a:headEnd type="none" w="med" len="med"/>
-                      <a:tailEnd type="none" w="med" len="med"/>
-                    </a:lnL>
-                    <a:lnR w="9525" cap="flat" cmpd="sng" algn="ctr">
-                      <a:solidFill>
-                        <a:srgbClr val="E8D8C4"/>
-                      </a:solidFill>
-                      <a:prstDash val="solid"/>
-                      <a:round/>
-                      <a:headEnd type="none" w="med" len="med"/>
-                      <a:tailEnd type="none" w="med" len="med"/>
-                    </a:lnR>
-                    <a:lnT w="9525" cap="flat" cmpd="sng" algn="ctr">
-                      <a:solidFill>
-                        <a:srgbClr val="E8D8C4"/>
-                      </a:solidFill>
-                      <a:prstDash val="solid"/>
-                      <a:round/>
-                      <a:headEnd type="none" w="med" len="med"/>
-                      <a:tailEnd type="none" w="med" len="med"/>
-                    </a:lnT>
-                    <a:lnB w="9525" cap="flat" cmpd="sng" algn="ctr">
-                      <a:solidFill>
-                        <a:srgbClr val="E8D8C4"/>
-                      </a:solidFill>
-                      <a:prstDash val="solid"/>
-                      <a:round/>
-                      <a:headEnd type="none" w="med" len="med"/>
-                      <a:tailEnd type="none" w="med" len="med"/>
-                    </a:lnB>
-                    <a:solidFill>
-                      <a:srgbClr val="FFFFFF"/>
-                    </a:solidFill>
-                  </a:tcPr>
-                </a:tc>
-                <a:tc>
-                  <a:txBody>
-                    <a:bodyPr/>
-                    <a:lstStyle/>
-                    <a:p>
-                      <a:pPr indent="0" marL="0">
-                        <a:buNone/>
-                      </a:pPr>
-                      <a:r>
-                        <a:rPr lang="en-US" sz="1200" b="1" dirty="0">
-                          <a:solidFill>
-                            <a:schemeClr val="accent1"/>
-                          </a:solidFill>
-                        </a:rPr>
-                        <a:t>Mantener canales</a:t>
-                      </a:r>
-                      <a:endParaRPr lang="en-US" sz="1200" dirty="0"/>
-                    </a:p>
-                  </a:txBody>
-                  <a:tcPr marL="64008" marR="64008" marT="64008" marB="64008" anchor="ctr">
-                    <a:lnL w="9525" cap="flat" cmpd="sng" algn="ctr">
-                      <a:solidFill>
-                        <a:srgbClr val="E8D8C4"/>
-                      </a:solidFill>
-                      <a:prstDash val="solid"/>
-                      <a:round/>
-                      <a:headEnd type="none" w="med" len="med"/>
-                      <a:tailEnd type="none" w="med" len="med"/>
-                    </a:lnL>
-                    <a:lnR w="9525" cap="flat" cmpd="sng" algn="ctr">
-                      <a:solidFill>
-                        <a:srgbClr val="E8D8C4"/>
-                      </a:solidFill>
-                      <a:prstDash val="solid"/>
-                      <a:round/>
-                      <a:headEnd type="none" w="med" len="med"/>
-                      <a:tailEnd type="none" w="med" len="med"/>
-                    </a:lnR>
-                    <a:lnT w="9525" cap="flat" cmpd="sng" algn="ctr">
-                      <a:solidFill>
-                        <a:srgbClr val="E8D8C4"/>
-                      </a:solidFill>
-                      <a:prstDash val="solid"/>
-                      <a:round/>
-                      <a:headEnd type="none" w="med" len="med"/>
-                      <a:tailEnd type="none" w="med" len="med"/>
-                    </a:lnT>
-                    <a:lnB w="9525" cap="flat" cmpd="sng" algn="ctr">
-                      <a:solidFill>
-                        <a:srgbClr val="E8D8C4"/>
-                      </a:solidFill>
-                      <a:prstDash val="solid"/>
-                      <a:round/>
-                      <a:headEnd type="none" w="med" len="med"/>
-                      <a:tailEnd type="none" w="med" len="med"/>
-                    </a:lnB>
-                    <a:solidFill>
-                      <a:srgbClr val="FFFFFF"/>
-                    </a:solidFill>
-                  </a:tcPr>
-                </a:tc>
-                <a:tc>
-                  <a:txBody>
-                    <a:bodyPr/>
-                    <a:lstStyle/>
-                    <a:p>
-                      <a:pPr indent="0" marL="0">
-                        <a:buNone/>
-                      </a:pPr>
-                      <a:r>
-                        <a:rPr lang="en-US" sz="1300" dirty="0">
-                          <a:solidFill>
-                            <a:schemeClr val="tx1"/>
-                          </a:solidFill>
-                        </a:rPr>
-                        <a:t>S/250 al mes + S/0.04 por código impreso</a:t>
-                      </a:r>
-                      <a:endParaRPr lang="en-US" sz="1300" dirty="0"/>
-                    </a:p>
-                  </a:txBody>
-                  <a:tcPr marL="64008" marR="64008" marT="64008" marB="64008" anchor="ctr">
-                    <a:lnL w="9525" cap="flat" cmpd="sng" algn="ctr">
-                      <a:solidFill>
-                        <a:srgbClr val="E8D8C4"/>
-                      </a:solidFill>
-                      <a:prstDash val="solid"/>
-                      <a:round/>
-                      <a:headEnd type="none" w="med" len="med"/>
-                      <a:tailEnd type="none" w="med" len="med"/>
-                    </a:lnL>
-                    <a:lnR w="9525" cap="flat" cmpd="sng" algn="ctr">
-                      <a:solidFill>
-                        <a:srgbClr val="E8D8C4"/>
-                      </a:solidFill>
-                      <a:prstDash val="solid"/>
-                      <a:round/>
-                      <a:headEnd type="none" w="med" len="med"/>
-                      <a:tailEnd type="none" w="med" len="med"/>
-                    </a:lnR>
-                    <a:lnT w="9525" cap="flat" cmpd="sng" algn="ctr">
-                      <a:solidFill>
-                        <a:srgbClr val="E8D8C4"/>
-                      </a:solidFill>
-                      <a:prstDash val="solid"/>
-                      <a:round/>
-                      <a:headEnd type="none" w="med" len="med"/>
-                      <a:tailEnd type="none" w="med" len="med"/>
-                    </a:lnT>
-                    <a:lnB w="9525" cap="flat" cmpd="sng" algn="ctr">
-                      <a:solidFill>
-                        <a:srgbClr val="E8D8C4"/>
-                      </a:solidFill>
-                      <a:prstDash val="solid"/>
-                      <a:round/>
-                      <a:headEnd type="none" w="med" len="med"/>
-                      <a:tailEnd type="none" w="med" len="med"/>
-                    </a:lnB>
-                    <a:solidFill>
-                      <a:srgbClr val="FFFFFF"/>
-                    </a:solidFill>
-                  </a:tcPr>
-                </a:tc>
-                <a:tc>
-                  <a:txBody>
-                    <a:bodyPr/>
-                    <a:lstStyle/>
-                    <a:p>
-                      <a:pPr indent="0" marL="0">
-                        <a:buNone/>
-                      </a:pPr>
-                      <a:r>
-                        <a:rPr lang="en-US" sz="1200" dirty="0">
-                          <a:solidFill>
-                            <a:schemeClr val="accent2"/>
-                          </a:solidFill>
-                        </a:rPr>
-                        <a:t>Fijo y variable</a:t>
-                      </a:r>
-                      <a:endParaRPr lang="en-US" sz="1200" dirty="0"/>
-                    </a:p>
-                  </a:txBody>
-                  <a:tcPr marL="64008" marR="64008" marT="64008" marB="64008" anchor="ctr">
-                    <a:lnL w="9525" cap="flat" cmpd="sng" algn="ctr">
-                      <a:solidFill>
-                        <a:srgbClr val="E8D8C4"/>
-                      </a:solidFill>
-                      <a:prstDash val="solid"/>
-                      <a:round/>
-                      <a:headEnd type="none" w="med" len="med"/>
-                      <a:tailEnd type="none" w="med" len="med"/>
-                    </a:lnL>
-                    <a:lnR w="9525" cap="flat" cmpd="sng" algn="ctr">
-                      <a:solidFill>
-                        <a:srgbClr val="E8D8C4"/>
-                      </a:solidFill>
-                      <a:prstDash val="solid"/>
-                      <a:round/>
-                      <a:headEnd type="none" w="med" len="med"/>
-                      <a:tailEnd type="none" w="med" len="med"/>
-                    </a:lnR>
-                    <a:lnT w="9525" cap="flat" cmpd="sng" algn="ctr">
-                      <a:solidFill>
-                        <a:srgbClr val="E8D8C4"/>
-                      </a:solidFill>
-                      <a:prstDash val="solid"/>
-                      <a:round/>
-                      <a:headEnd type="none" w="med" len="med"/>
-                      <a:tailEnd type="none" w="med" len="med"/>
-                    </a:lnT>
-                    <a:lnB w="9525" cap="flat" cmpd="sng" algn="ctr">
-                      <a:solidFill>
-                        <a:srgbClr val="E8D8C4"/>
-                      </a:solidFill>
-                      <a:prstDash val="solid"/>
-                      <a:round/>
-                      <a:headEnd type="none" w="med" len="med"/>
-                      <a:tailEnd type="none" w="med" len="med"/>
-                    </a:lnB>
-                    <a:solidFill>
-                      <a:srgbClr val="FBF3E8"/>
-                    </a:solidFill>
-                  </a:tcPr>
-                </a:tc>
-              </a:tr>
-              <a:tr h="457200">
-                <a:tc>
-                  <a:txBody>
-                    <a:bodyPr/>
-                    <a:lstStyle/>
-                    <a:p>
-                      <a:pPr indent="0" marL="0">
-                        <a:buNone/>
-                      </a:pPr>
-                      <a:r>
-                        <a:rPr lang="en-US" sz="1300" b="1" dirty="0">
-                          <a:solidFill>
-                            <a:schemeClr val="tx1"/>
-                          </a:solidFill>
-                        </a:rPr>
-                        <a:t>Administrar el negocio</a:t>
-                      </a:r>
-                      <a:endParaRPr lang="en-US" sz="1300" dirty="0"/>
-                    </a:p>
-                  </a:txBody>
-                  <a:tcPr marL="64008" marR="64008" marT="64008" marB="64008" anchor="ctr">
-                    <a:lnL w="9525" cap="flat" cmpd="sng" algn="ctr">
-                      <a:solidFill>
-                        <a:srgbClr val="E8D8C4"/>
-                      </a:solidFill>
-                      <a:prstDash val="solid"/>
-                      <a:round/>
-                      <a:headEnd type="none" w="med" len="med"/>
-                      <a:tailEnd type="none" w="med" len="med"/>
-                    </a:lnL>
-                    <a:lnR w="9525" cap="flat" cmpd="sng" algn="ctr">
-                      <a:solidFill>
-                        <a:srgbClr val="E8D8C4"/>
-                      </a:solidFill>
-                      <a:prstDash val="solid"/>
-                      <a:round/>
-                      <a:headEnd type="none" w="med" len="med"/>
-                      <a:tailEnd type="none" w="med" len="med"/>
-                    </a:lnR>
-                    <a:lnT w="9525" cap="flat" cmpd="sng" algn="ctr">
-                      <a:solidFill>
-                        <a:srgbClr val="E8D8C4"/>
-                      </a:solidFill>
-                      <a:prstDash val="solid"/>
-                      <a:round/>
-                      <a:headEnd type="none" w="med" len="med"/>
-                      <a:tailEnd type="none" w="med" len="med"/>
-                    </a:lnT>
-                    <a:lnB w="9525" cap="flat" cmpd="sng" algn="ctr">
-                      <a:solidFill>
-                        <a:srgbClr val="E8D8C4"/>
-                      </a:solidFill>
-                      <a:prstDash val="solid"/>
-                      <a:round/>
-                      <a:headEnd type="none" w="med" len="med"/>
-                      <a:tailEnd type="none" w="med" len="med"/>
-                    </a:lnB>
-                    <a:solidFill>
-                      <a:srgbClr val="FFFFFF"/>
-                    </a:solidFill>
-                  </a:tcPr>
-                </a:tc>
-                <a:tc>
-                  <a:txBody>
-                    <a:bodyPr/>
-                    <a:lstStyle/>
-                    <a:p>
-                      <a:pPr indent="0" marL="0">
-                        <a:buNone/>
-                      </a:pPr>
-                      <a:r>
-                        <a:rPr lang="en-US" sz="1200" b="1" dirty="0">
-                          <a:solidFill>
-                            <a:schemeClr val="accent1"/>
-                          </a:solidFill>
-                        </a:rPr>
-                        <a:t>Gestión</a:t>
-                      </a:r>
-                      <a:endParaRPr lang="en-US" sz="1200" dirty="0"/>
-                    </a:p>
-                  </a:txBody>
-                  <a:tcPr marL="64008" marR="64008" marT="64008" marB="64008" anchor="ctr">
-                    <a:lnL w="9525" cap="flat" cmpd="sng" algn="ctr">
-                      <a:solidFill>
-                        <a:srgbClr val="E8D8C4"/>
-                      </a:solidFill>
-                      <a:prstDash val="solid"/>
-                      <a:round/>
-                      <a:headEnd type="none" w="med" len="med"/>
-                      <a:tailEnd type="none" w="med" len="med"/>
-                    </a:lnL>
-                    <a:lnR w="9525" cap="flat" cmpd="sng" algn="ctr">
-                      <a:solidFill>
-                        <a:srgbClr val="E8D8C4"/>
-                      </a:solidFill>
-                      <a:prstDash val="solid"/>
-                      <a:round/>
-                      <a:headEnd type="none" w="med" len="med"/>
-                      <a:tailEnd type="none" w="med" len="med"/>
-                    </a:lnR>
-                    <a:lnT w="9525" cap="flat" cmpd="sng" algn="ctr">
-                      <a:solidFill>
-                        <a:srgbClr val="E8D8C4"/>
-                      </a:solidFill>
-                      <a:prstDash val="solid"/>
-                      <a:round/>
-                      <a:headEnd type="none" w="med" len="med"/>
-                      <a:tailEnd type="none" w="med" len="med"/>
-                    </a:lnT>
-                    <a:lnB w="9525" cap="flat" cmpd="sng" algn="ctr">
-                      <a:solidFill>
-                        <a:srgbClr val="E8D8C4"/>
-                      </a:solidFill>
-                      <a:prstDash val="solid"/>
-                      <a:round/>
-                      <a:headEnd type="none" w="med" len="med"/>
-                      <a:tailEnd type="none" w="med" len="med"/>
-                    </a:lnB>
-                    <a:solidFill>
-                      <a:srgbClr val="FFFFFF"/>
-                    </a:solidFill>
-                  </a:tcPr>
-                </a:tc>
-                <a:tc>
-                  <a:txBody>
-                    <a:bodyPr/>
-                    <a:lstStyle/>
-                    <a:p>
-                      <a:pPr indent="0" marL="0">
-                        <a:buNone/>
-                      </a:pPr>
-                      <a:r>
-                        <a:rPr lang="en-US" sz="1300" dirty="0">
-                          <a:solidFill>
-                            <a:schemeClr val="tx1"/>
-                          </a:solidFill>
-                        </a:rPr>
-                        <a:t>S/745 de administración + S/709 de la coordinadora al mes</a:t>
-                      </a:r>
-                      <a:endParaRPr lang="en-US" sz="1300" dirty="0"/>
-                    </a:p>
-                  </a:txBody>
-                  <a:tcPr marL="64008" marR="64008" marT="64008" marB="64008" anchor="ctr">
-                    <a:lnL w="9525" cap="flat" cmpd="sng" algn="ctr">
-                      <a:solidFill>
-                        <a:srgbClr val="E8D8C4"/>
-                      </a:solidFill>
-                      <a:prstDash val="solid"/>
-                      <a:round/>
-                      <a:headEnd type="none" w="med" len="med"/>
-                      <a:tailEnd type="none" w="med" len="med"/>
-                    </a:lnL>
-                    <a:lnR w="9525" cap="flat" cmpd="sng" algn="ctr">
-                      <a:solidFill>
-                        <a:srgbClr val="E8D8C4"/>
-                      </a:solidFill>
-                      <a:prstDash val="solid"/>
-                      <a:round/>
-                      <a:headEnd type="none" w="med" len="med"/>
-                      <a:tailEnd type="none" w="med" len="med"/>
-                    </a:lnR>
-                    <a:lnT w="9525" cap="flat" cmpd="sng" algn="ctr">
-                      <a:solidFill>
-                        <a:srgbClr val="E8D8C4"/>
-                      </a:solidFill>
-                      <a:prstDash val="solid"/>
-                      <a:round/>
-                      <a:headEnd type="none" w="med" len="med"/>
-                      <a:tailEnd type="none" w="med" len="med"/>
-                    </a:lnT>
-                    <a:lnB w="9525" cap="flat" cmpd="sng" algn="ctr">
-                      <a:solidFill>
-                        <a:srgbClr val="E8D8C4"/>
-                      </a:solidFill>
-                      <a:prstDash val="solid"/>
-                      <a:round/>
-                      <a:headEnd type="none" w="med" len="med"/>
-                      <a:tailEnd type="none" w="med" len="med"/>
-                    </a:lnB>
-                    <a:solidFill>
-                      <a:srgbClr val="FFFFFF"/>
-                    </a:solidFill>
-                  </a:tcPr>
-                </a:tc>
-                <a:tc>
-                  <a:txBody>
-                    <a:bodyPr/>
-                    <a:lstStyle/>
-                    <a:p>
-                      <a:pPr indent="0" marL="0">
-                        <a:buNone/>
-                      </a:pPr>
-                      <a:r>
-                        <a:rPr lang="en-US" sz="1200" dirty="0">
-                          <a:solidFill>
-                            <a:schemeClr val="accent2"/>
-                          </a:solidFill>
-                        </a:rPr>
-                        <a:t>Fijo</a:t>
-                      </a:r>
-                      <a:endParaRPr lang="en-US" sz="1200" dirty="0"/>
-                    </a:p>
-                  </a:txBody>
-                  <a:tcPr marL="64008" marR="64008" marT="64008" marB="64008" anchor="ctr">
-                    <a:lnL w="9525" cap="flat" cmpd="sng" algn="ctr">
-                      <a:solidFill>
-                        <a:srgbClr val="E8D8C4"/>
-                      </a:solidFill>
-                      <a:prstDash val="solid"/>
-                      <a:round/>
-                      <a:headEnd type="none" w="med" len="med"/>
-                      <a:tailEnd type="none" w="med" len="med"/>
-                    </a:lnL>
-                    <a:lnR w="9525" cap="flat" cmpd="sng" algn="ctr">
-                      <a:solidFill>
-                        <a:srgbClr val="E8D8C4"/>
-                      </a:solidFill>
-                      <a:prstDash val="solid"/>
-                      <a:round/>
-                      <a:headEnd type="none" w="med" len="med"/>
-                      <a:tailEnd type="none" w="med" len="med"/>
-                    </a:lnR>
-                    <a:lnT w="9525" cap="flat" cmpd="sng" algn="ctr">
-                      <a:solidFill>
-                        <a:srgbClr val="E8D8C4"/>
-                      </a:solidFill>
-                      <a:prstDash val="solid"/>
-                      <a:round/>
-                      <a:headEnd type="none" w="med" len="med"/>
-                      <a:tailEnd type="none" w="med" len="med"/>
-                    </a:lnT>
-                    <a:lnB w="9525" cap="flat" cmpd="sng" algn="ctr">
-                      <a:solidFill>
-                        <a:srgbClr val="E8D8C4"/>
-                      </a:solidFill>
-                      <a:prstDash val="solid"/>
-                      <a:round/>
-                      <a:headEnd type="none" w="med" len="med"/>
-                      <a:tailEnd type="none" w="med" len="med"/>
-                    </a:lnB>
-                    <a:solidFill>
-                      <a:srgbClr val="FFFFFF"/>
-                    </a:solidFill>
-                  </a:tcPr>
-                </a:tc>
-              </a:tr>
             </a:tbl>
           </a:graphicData>
         </a:graphic>
@@ -28750,7 +28750,7 @@
         </p:nvSpPr>
         <p:spPr>
           <a:xfrm>
-            <a:off x="694944" y="1984248"/>
+            <a:off x="694944" y="2011680"/>
             <a:ext cx="365760" cy="365760"/>
           </a:xfrm>
           <a:prstGeom prst="ellipse">
@@ -28783,7 +28783,7 @@
         </p:blipFill>
         <p:spPr>
           <a:xfrm>
-            <a:off x="775411" y="2064715"/>
+            <a:off x="775411" y="2092147"/>
             <a:ext cx="204826" cy="204826"/>
           </a:xfrm>
           <a:prstGeom prst="rect">
@@ -28799,7 +28799,7 @@
         </p:nvSpPr>
         <p:spPr>
           <a:xfrm>
-            <a:off x="694944" y="2441448"/>
+            <a:off x="694944" y="2596896"/>
             <a:ext cx="365760" cy="365760"/>
           </a:xfrm>
           <a:prstGeom prst="ellipse">
@@ -28832,7 +28832,7 @@
         </p:blipFill>
         <p:spPr>
           <a:xfrm>
-            <a:off x="775411" y="2521915"/>
+            <a:off x="775411" y="2677363"/>
             <a:ext cx="204826" cy="204826"/>
           </a:xfrm>
           <a:prstGeom prst="rect">
@@ -28848,7 +28848,7 @@
         </p:nvSpPr>
         <p:spPr>
           <a:xfrm>
-            <a:off x="694944" y="2898648"/>
+            <a:off x="694944" y="3108960"/>
             <a:ext cx="365760" cy="365760"/>
           </a:xfrm>
           <a:prstGeom prst="ellipse">
@@ -28881,7 +28881,7 @@
         </p:blipFill>
         <p:spPr>
           <a:xfrm>
-            <a:off x="775411" y="2979115"/>
+            <a:off x="775411" y="3189427"/>
             <a:ext cx="204826" cy="204826"/>
           </a:xfrm>
           <a:prstGeom prst="rect">
@@ -28897,7 +28897,7 @@
         </p:nvSpPr>
         <p:spPr>
           <a:xfrm>
-            <a:off x="694944" y="3355848"/>
+            <a:off x="694944" y="3547872"/>
             <a:ext cx="365760" cy="365760"/>
           </a:xfrm>
           <a:prstGeom prst="ellipse">
@@ -28930,7 +28930,7 @@
         </p:blipFill>
         <p:spPr>
           <a:xfrm>
-            <a:off x="775411" y="3436315"/>
+            <a:off x="775411" y="3628339"/>
             <a:ext cx="204826" cy="204826"/>
           </a:xfrm>
           <a:prstGeom prst="rect">
@@ -28946,7 +28946,7 @@
         </p:nvSpPr>
         <p:spPr>
           <a:xfrm>
-            <a:off x="694944" y="3813048"/>
+            <a:off x="694944" y="3986784"/>
             <a:ext cx="365760" cy="365760"/>
           </a:xfrm>
           <a:prstGeom prst="ellipse">
@@ -28979,7 +28979,7 @@
         </p:blipFill>
         <p:spPr>
           <a:xfrm>
-            <a:off x="775411" y="3893515"/>
+            <a:off x="775411" y="4067251"/>
             <a:ext cx="204826" cy="204826"/>
           </a:xfrm>
           <a:prstGeom prst="rect">
@@ -28995,7 +28995,7 @@
         </p:nvSpPr>
         <p:spPr>
           <a:xfrm>
-            <a:off x="694944" y="4270248"/>
+            <a:off x="694944" y="4425696"/>
             <a:ext cx="365760" cy="365760"/>
           </a:xfrm>
           <a:prstGeom prst="ellipse">
@@ -29028,7 +29028,7 @@
         </p:blipFill>
         <p:spPr>
           <a:xfrm>
-            <a:off x="775411" y="4350715"/>
+            <a:off x="775411" y="4506163"/>
             <a:ext cx="204826" cy="204826"/>
           </a:xfrm>
           <a:prstGeom prst="rect">
@@ -29044,7 +29044,7 @@
         </p:nvSpPr>
         <p:spPr>
           <a:xfrm>
-            <a:off x="694944" y="4727448"/>
+            <a:off x="694944" y="4864608"/>
             <a:ext cx="365760" cy="365760"/>
           </a:xfrm>
           <a:prstGeom prst="ellipse">
@@ -29077,7 +29077,7 @@
         </p:blipFill>
         <p:spPr>
           <a:xfrm>
-            <a:off x="775411" y="4807915"/>
+            <a:off x="775411" y="4945075"/>
             <a:ext cx="204826" cy="204826"/>
           </a:xfrm>
           <a:prstGeom prst="rect">
@@ -29093,7 +29093,7 @@
         </p:nvSpPr>
         <p:spPr>
           <a:xfrm>
-            <a:off x="694944" y="5184648"/>
+            <a:off x="694944" y="5303520"/>
             <a:ext cx="365760" cy="365760"/>
           </a:xfrm>
           <a:prstGeom prst="ellipse">
@@ -29126,7 +29126,7 @@
         </p:blipFill>
         <p:spPr>
           <a:xfrm>
-            <a:off x="775411" y="5265115"/>
+            <a:off x="775411" y="5383987"/>
             <a:ext cx="204826" cy="204826"/>
           </a:xfrm>
           <a:prstGeom prst="rect">

</xml_diff>